<commit_message>
feat: make RAG indexing source-first
</commit_message>
<xml_diff>
--- a/deliverables/rfp-rag-baseline-presentation.pptx
+++ b/deliverables/rfp-rag-baseline-presentation.pptx
@@ -2,22 +2,22 @@
 <file path=ppt/presentation.xml><?xml version="1.0" encoding="utf-8"?>
 <p:presentation xmlns:p="http://schemas.openxmlformats.org/presentationml/2006/main">
   <p:sldMasterIdLst>
-    <p:sldMasterId xmlns:r="http://schemas.openxmlformats.org/officeDocument/2006/relationships" id="2147483648" r:id="R7241223d4d69459a"/>
+    <p:sldMasterId xmlns:r="http://schemas.openxmlformats.org/officeDocument/2006/relationships" id="2147483648" r:id="Raae3474ef467441f"/>
   </p:sldMasterIdLst>
   <p:notesMasterIdLst>
-    <p:notesMasterId xmlns:r="http://schemas.openxmlformats.org/officeDocument/2006/relationships" r:id="R96ced08343d74b7d"/>
+    <p:notesMasterId xmlns:r="http://schemas.openxmlformats.org/officeDocument/2006/relationships" r:id="Red819761829e4251"/>
   </p:notesMasterIdLst>
   <p:sldIdLst>
-    <p:sldId xmlns:r="http://schemas.openxmlformats.org/officeDocument/2006/relationships" id="256" r:id="R5b6eba0902a94840"/>
-    <p:sldId xmlns:r="http://schemas.openxmlformats.org/officeDocument/2006/relationships" id="257" r:id="R080819bf2faf48c3"/>
-    <p:sldId xmlns:r="http://schemas.openxmlformats.org/officeDocument/2006/relationships" id="258" r:id="Rb5ec467e924a478f"/>
-    <p:sldId xmlns:r="http://schemas.openxmlformats.org/officeDocument/2006/relationships" id="259" r:id="R73054ffc451540e7"/>
-    <p:sldId xmlns:r="http://schemas.openxmlformats.org/officeDocument/2006/relationships" id="260" r:id="R66a4713e382142ff"/>
-    <p:sldId xmlns:r="http://schemas.openxmlformats.org/officeDocument/2006/relationships" id="261" r:id="R43f509ad4e564bc8"/>
-    <p:sldId xmlns:r="http://schemas.openxmlformats.org/officeDocument/2006/relationships" id="262" r:id="Rd54caa3d50a3429e"/>
-    <p:sldId xmlns:r="http://schemas.openxmlformats.org/officeDocument/2006/relationships" id="263" r:id="R80586658b7334ae8"/>
-    <p:sldId xmlns:r="http://schemas.openxmlformats.org/officeDocument/2006/relationships" id="264" r:id="R0e0f64baf19f4e79"/>
-    <p:sldId xmlns:r="http://schemas.openxmlformats.org/officeDocument/2006/relationships" id="265" r:id="R3cca31c58ec64658"/>
+    <p:sldId xmlns:r="http://schemas.openxmlformats.org/officeDocument/2006/relationships" id="256" r:id="R18d5d5c917c64e71"/>
+    <p:sldId xmlns:r="http://schemas.openxmlformats.org/officeDocument/2006/relationships" id="257" r:id="R58e9a73166eb4679"/>
+    <p:sldId xmlns:r="http://schemas.openxmlformats.org/officeDocument/2006/relationships" id="258" r:id="Rc49accc801754309"/>
+    <p:sldId xmlns:r="http://schemas.openxmlformats.org/officeDocument/2006/relationships" id="259" r:id="Rd691292cf84b481e"/>
+    <p:sldId xmlns:r="http://schemas.openxmlformats.org/officeDocument/2006/relationships" id="260" r:id="R13325a34dadc407a"/>
+    <p:sldId xmlns:r="http://schemas.openxmlformats.org/officeDocument/2006/relationships" id="261" r:id="R4716dfe2efae4a44"/>
+    <p:sldId xmlns:r="http://schemas.openxmlformats.org/officeDocument/2006/relationships" id="262" r:id="R9b6cdd75cb324f18"/>
+    <p:sldId xmlns:r="http://schemas.openxmlformats.org/officeDocument/2006/relationships" id="263" r:id="Rb27d0f2e4d104ca8"/>
+    <p:sldId xmlns:r="http://schemas.openxmlformats.org/officeDocument/2006/relationships" id="264" r:id="Ra295da85470b4afa"/>
+    <p:sldId xmlns:r="http://schemas.openxmlformats.org/officeDocument/2006/relationships" id="265" r:id="R6ebbe30f76df4280"/>
   </p:sldIdLst>
   <p:sldSz cx="12192000" cy="6858000"/>
   <p:notesSz cx="6858000" cy="9144000"/>
@@ -261,7 +261,7 @@
 </p:notesMaster>
 </file>
 
-<file path=ppt/notesMasters/theme/theme2.xml><?xml version="1.0" encoding="utf-8"?>
+<file path=ppt/notesMasters/theme/theme3.xml><?xml version="1.0" encoding="utf-8"?>
 <a:theme xmlns:a="http://schemas.openxmlformats.org/drawingml/2006/main" name="ChatGPT">
   <a:themeElements>
     <a:clrScheme name="ChatGPT">
@@ -1120,7 +1120,7 @@
 </p:notes>
 </file>
 
-<file path=ppt/slideLayouts/slideLayout2.xml><?xml version="1.0" encoding="utf-8"?>
+<file path=ppt/slideLayouts/slideLayout1.xml><?xml version="1.0" encoding="utf-8"?>
 <p:sldLayout xmlns:p="http://schemas.openxmlformats.org/presentationml/2006/main" type="title">
   <p:cSld name="Title Slide">
     <p:spTree>
@@ -1158,7 +1158,7 @@
   </p:cSld>
   <p:clrMap bg1="lt1" tx1="dk1" bg2="lt2" tx2="dk2" accent1="accent1" accent2="accent2" accent3="accent3" accent4="accent4" accent5="accent5" accent6="accent6" hlink="hlink" folHlink="folHlink"/>
   <p:sldLayoutIdLst>
-    <p:sldLayoutId xmlns:r="http://schemas.openxmlformats.org/officeDocument/2006/relationships" id="2147483649" r:id="R465aea5dc9d14fbf"/>
+    <p:sldLayoutId xmlns:r="http://schemas.openxmlformats.org/officeDocument/2006/relationships" id="2147483649" r:id="R7bcb0004e9f748c8"/>
   </p:sldLayoutIdLst>
   <p:txStyles>
     <p:titleStyle>
@@ -1440,6 +1440,205 @@
 </p:sldMaster>
 </file>
 
+<file path=ppt/slideMasters/theme/theme2.xml><?xml version="1.0" encoding="utf-8"?>
+<a:theme xmlns:a="http://schemas.openxmlformats.org/drawingml/2006/main" name="ChatGPT">
+  <a:themeElements>
+    <a:clrScheme name="ChatGPT">
+      <a:dk1>
+        <a:srgbClr val="000000"/>
+      </a:dk1>
+      <a:lt1>
+        <a:srgbClr val="FFFFFF"/>
+      </a:lt1>
+      <a:dk2>
+        <a:srgbClr val="0E2841"/>
+      </a:dk2>
+      <a:lt2>
+        <a:srgbClr val="E8E8E8"/>
+      </a:lt2>
+      <a:accent1>
+        <a:srgbClr val="156082"/>
+      </a:accent1>
+      <a:accent2>
+        <a:srgbClr val="E97132"/>
+      </a:accent2>
+      <a:accent3>
+        <a:srgbClr val="196B24"/>
+      </a:accent3>
+      <a:accent4>
+        <a:srgbClr val="0F9ED5"/>
+      </a:accent4>
+      <a:accent5>
+        <a:srgbClr val="A02B93"/>
+      </a:accent5>
+      <a:accent6>
+        <a:srgbClr val="4EA72E"/>
+      </a:accent6>
+      <a:hlink>
+        <a:srgbClr val="467886"/>
+      </a:hlink>
+      <a:folHlink>
+        <a:srgbClr val="96607D"/>
+      </a:folHlink>
+    </a:clrScheme>
+    <a:fontScheme name="Office">
+      <a:majorFont>
+        <a:latin typeface="Calibri Light"/>
+        <a:ea typeface="Calibri Light"/>
+        <a:cs typeface="Calibri Light"/>
+      </a:majorFont>
+      <a:minorFont>
+        <a:latin typeface="Calibri"/>
+        <a:ea typeface="Calibri"/>
+        <a:cs typeface="Calibri"/>
+      </a:minorFont>
+    </a:fontScheme>
+    <a:fmtScheme name="ChatGPT">
+      <a:fillStyleLst>
+        <a:solidFill>
+          <a:schemeClr val="phClr"/>
+        </a:solidFill>
+        <a:solidFill>
+          <a:schemeClr val="dk1"/>
+        </a:solidFill>
+        <a:solidFill>
+          <a:schemeClr val="accent1"/>
+        </a:solidFill>
+      </a:fillStyleLst>
+      <a:lnStyleLst>
+        <a:ln w="12700">
+          <a:solidFill>
+            <a:schemeClr val="phClr"/>
+          </a:solidFill>
+          <a:prstDash val="solid"/>
+        </a:ln>
+        <a:ln w="19050">
+          <a:solidFill>
+            <a:schemeClr val="phClr"/>
+          </a:solidFill>
+          <a:prstDash val="solid"/>
+        </a:ln>
+        <a:ln w="25400">
+          <a:solidFill>
+            <a:schemeClr val="phClr"/>
+          </a:solidFill>
+          <a:prstDash val="solid"/>
+        </a:ln>
+      </a:lnStyleLst>
+      <a:effectStyleLst>
+        <a:effectStyle>
+          <a:effectLst/>
+        </a:effectStyle>
+        <a:effectStyle>
+          <a:effectLst/>
+        </a:effectStyle>
+        <a:effectStyle>
+          <a:effectLst>
+            <a:outerShdw blurRad="57150" dist="19050" dir="5400000">
+              <a:srgbClr val="000000">
+                <a:alpha val="16000"/>
+              </a:srgbClr>
+            </a:outerShdw>
+          </a:effectLst>
+        </a:effectStyle>
+        <a:effectStyle>
+          <a:effectLst>
+            <a:outerShdw blurRad="19050" dist="9525" dir="5400000">
+              <a:srgbClr val="000000">
+                <a:alpha val="6000"/>
+              </a:srgbClr>
+            </a:outerShdw>
+          </a:effectLst>
+        </a:effectStyle>
+        <a:effectStyle>
+          <a:effectLst>
+            <a:outerShdw blurRad="28575" dist="9525" dir="5400000">
+              <a:srgbClr val="000000">
+                <a:alpha val="8000"/>
+              </a:srgbClr>
+            </a:outerShdw>
+          </a:effectLst>
+        </a:effectStyle>
+        <a:effectStyle>
+          <a:effectLst>
+            <a:outerShdw blurRad="57150" dist="19050" dir="5400000">
+              <a:srgbClr val="000000">
+                <a:alpha val="10000"/>
+              </a:srgbClr>
+            </a:outerShdw>
+          </a:effectLst>
+        </a:effectStyle>
+        <a:effectStyle>
+          <a:effectLst>
+            <a:outerShdw blurRad="114300" dist="38100" dir="5400000">
+              <a:srgbClr val="000000">
+                <a:alpha val="12000"/>
+              </a:srgbClr>
+            </a:outerShdw>
+          </a:effectLst>
+        </a:effectStyle>
+        <a:effectStyle>
+          <a:effectLst>
+            <a:outerShdw blurRad="171450" dist="57150" dir="5400000">
+              <a:srgbClr val="000000">
+                <a:alpha val="16000"/>
+              </a:srgbClr>
+            </a:outerShdw>
+          </a:effectLst>
+        </a:effectStyle>
+        <a:effectStyle>
+          <a:effectLst>
+            <a:outerShdw blurRad="266700" dist="95250" dir="5400000">
+              <a:srgbClr val="000000">
+                <a:alpha val="24000"/>
+              </a:srgbClr>
+            </a:outerShdw>
+          </a:effectLst>
+        </a:effectStyle>
+      </a:effectStyleLst>
+      <a:bgFillStyleLst>
+        <a:solidFill>
+          <a:schemeClr val="phClr"/>
+        </a:solidFill>
+        <a:solidFill>
+          <a:schemeClr val="phClr">
+            <a:tint val="95000"/>
+            <a:satMod val="170000"/>
+          </a:schemeClr>
+        </a:solidFill>
+        <a:gradFill>
+          <a:gsLst>
+            <a:gs pos="0">
+              <a:schemeClr val="phClr">
+                <a:tint val="93000"/>
+                <a:shade val="98000"/>
+                <a:lumMod val="102000"/>
+                <a:satMod val="150000"/>
+              </a:schemeClr>
+            </a:gs>
+            <a:gs pos="50000">
+              <a:schemeClr val="phClr">
+                <a:tint val="98000"/>
+                <a:shade val="90000"/>
+                <a:lumMod val="103000"/>
+                <a:satMod val="130000"/>
+              </a:schemeClr>
+            </a:gs>
+            <a:gs pos="100000">
+              <a:schemeClr val="phClr">
+                <a:shade val="63000"/>
+                <a:satMod val="120000"/>
+              </a:schemeClr>
+            </a:gs>
+          </a:gsLst>
+          <a:lin ang="5400000" scaled="0"/>
+        </a:gradFill>
+      </a:bgFillStyleLst>
+    </a:fmtScheme>
+  </a:themeElements>
+</a:theme>
+</file>
+
 <file path=ppt/slides/slide1.xml><?xml version="1.0" encoding="utf-8"?>
 <p:sld xmlns:p="http://schemas.openxmlformats.org/presentationml/2006/main">
   <p:cSld>
@@ -1528,6 +1727,7 @@
           <a:lstStyle xmlns:a="http://schemas.openxmlformats.org/drawingml/2006/main"/>
           <a:p xmlns:a="http://schemas.openxmlformats.org/drawingml/2006/main">
             <a:pPr algn="l">
+              <a:buNone/>
               <a:defRPr sz="3750" b="1">
                 <a:solidFill>
                   <a:srgbClr val="0F172A"/>
@@ -1592,6 +1792,7 @@
           <a:lstStyle xmlns:a="http://schemas.openxmlformats.org/drawingml/2006/main"/>
           <a:p xmlns:a="http://schemas.openxmlformats.org/drawingml/2006/main">
             <a:pPr algn="l">
+              <a:buNone/>
               <a:defRPr sz="1875" b="0">
                 <a:solidFill>
                   <a:srgbClr val="1E293B"/>
@@ -1602,15 +1803,7 @@
               </a:defRPr>
             </a:pPr>
             <a:r>
-              <a:rPr sz="1875" b="0">
-                <a:solidFill>
-                  <a:srgbClr val="1E293B"/>
-                </a:solidFill>
-                <a:latin typeface="Apple SD Gothic Neo"/>
-                <a:ea typeface="Apple SD Gothic Neo"/>
-                <a:cs typeface="Apple SD Gothic Neo"/>
-              </a:rPr>
-              <a:t>입찰 제안요청서 100건을 대상으로 한 CSV-first 검색·질의응답·평가 파이프라인</a:t>
+              <a:t>입찰 제안요청서 100건의 원본 HWP/PDF 기반 검색·질의응답·평가 파이프라인</a:t>
             </a:r>
           </a:p>
         </p:txBody>
@@ -1690,6 +1883,7 @@
           <a:lstStyle xmlns:a="http://schemas.openxmlformats.org/drawingml/2006/main"/>
           <a:p xmlns:a="http://schemas.openxmlformats.org/drawingml/2006/main">
             <a:pPr algn="l">
+              <a:buNone/>
               <a:defRPr sz="975" b="1">
                 <a:solidFill>
                   <a:srgbClr val="059669"/>
@@ -1788,6 +1982,7 @@
           <a:lstStyle xmlns:a="http://schemas.openxmlformats.org/drawingml/2006/main"/>
           <a:p xmlns:a="http://schemas.openxmlformats.org/drawingml/2006/main">
             <a:pPr algn="l">
+              <a:buNone/>
               <a:defRPr sz="975" b="1">
                 <a:solidFill>
                   <a:srgbClr val="D97706"/>
@@ -1886,6 +2081,7 @@
           <a:lstStyle xmlns:a="http://schemas.openxmlformats.org/drawingml/2006/main"/>
           <a:p xmlns:a="http://schemas.openxmlformats.org/drawingml/2006/main">
             <a:pPr algn="l">
+              <a:buNone/>
               <a:defRPr sz="975" b="1">
                 <a:solidFill>
                   <a:srgbClr val="2563EB"/>
@@ -2016,6 +2212,7 @@
           <a:lstStyle xmlns:a="http://schemas.openxmlformats.org/drawingml/2006/main"/>
           <a:p xmlns:a="http://schemas.openxmlformats.org/drawingml/2006/main">
             <a:pPr algn="l">
+              <a:buNone/>
               <a:defRPr sz="1800" b="1">
                 <a:solidFill>
                   <a:srgbClr val="2563EB"/>
@@ -2026,15 +2223,7 @@
               </a:defRPr>
             </a:pPr>
             <a:r>
-              <a:rPr sz="1800" b="1">
-                <a:solidFill>
-                  <a:srgbClr val="2563EB"/>
-                </a:solidFill>
-                <a:latin typeface="Apple SD Gothic Neo"/>
-                <a:ea typeface="Apple SD Gothic Neo"/>
-                <a:cs typeface="Apple SD Gothic Neo"/>
-              </a:rPr>
-              <a:t>CSV 텍스트</a:t>
+              <a:t>Parsed HWP/PDF</a:t>
             </a:r>
           </a:p>
         </p:txBody>
@@ -2112,6 +2301,7 @@
           <a:lstStyle xmlns:a="http://schemas.openxmlformats.org/drawingml/2006/main"/>
           <a:p xmlns:a="http://schemas.openxmlformats.org/drawingml/2006/main">
             <a:pPr algn="l">
+              <a:buNone/>
               <a:defRPr sz="1500" b="1">
                 <a:solidFill>
                   <a:srgbClr val="0F172A"/>
@@ -2208,6 +2398,7 @@
           <a:lstStyle xmlns:a="http://schemas.openxmlformats.org/drawingml/2006/main"/>
           <a:p xmlns:a="http://schemas.openxmlformats.org/drawingml/2006/main">
             <a:pPr algn="l">
+              <a:buNone/>
               <a:defRPr sz="1650" b="1">
                 <a:solidFill>
                   <a:srgbClr val="059669"/>
@@ -2340,6 +2531,7 @@
           <a:lstStyle xmlns:a="http://schemas.openxmlformats.org/drawingml/2006/main"/>
           <a:p xmlns:a="http://schemas.openxmlformats.org/drawingml/2006/main">
             <a:pPr algn="l">
+              <a:buNone/>
               <a:defRPr sz="1650" b="1">
                 <a:solidFill>
                   <a:srgbClr val="0F172A"/>
@@ -2404,6 +2596,7 @@
           <a:lstStyle xmlns:a="http://schemas.openxmlformats.org/drawingml/2006/main"/>
           <a:p xmlns:a="http://schemas.openxmlformats.org/drawingml/2006/main">
             <a:pPr algn="l">
+              <a:buNone/>
               <a:defRPr sz="1050" b="0">
                 <a:solidFill>
                   <a:srgbClr val="64748B"/>
@@ -2414,15 +2607,7 @@
               </a:defRPr>
             </a:pPr>
             <a:r>
-              <a:rPr sz="1050" b="0">
-                <a:solidFill>
-                  <a:srgbClr val="64748B"/>
-                </a:solidFill>
-                <a:latin typeface="Aptos"/>
-                <a:ea typeface="Aptos"/>
-                <a:cs typeface="Aptos"/>
-              </a:rPr>
-              <a:t>RFP RAG Baseline · CSV-first offline scaffold</a:t>
+              <a:t>RFP RAG Baseline · source-first offline scaffold</a:t>
             </a:r>
           </a:p>
         </p:txBody>
@@ -2468,6 +2653,7 @@
           <a:lstStyle xmlns:a="http://schemas.openxmlformats.org/drawingml/2006/main"/>
           <a:p xmlns:a="http://schemas.openxmlformats.org/drawingml/2006/main">
             <a:pPr algn="r">
+              <a:buNone/>
               <a:defRPr sz="1050" b="0">
                 <a:solidFill>
                   <a:srgbClr val="64748B"/>
@@ -2589,6 +2775,7 @@
           <a:lstStyle xmlns:a="http://schemas.openxmlformats.org/drawingml/2006/main"/>
           <a:p xmlns:a="http://schemas.openxmlformats.org/drawingml/2006/main">
             <a:pPr algn="l">
+              <a:buNone/>
               <a:defRPr sz="2550" b="1">
                 <a:solidFill>
                   <a:srgbClr val="0F172A"/>
@@ -2653,6 +2840,7 @@
           <a:lstStyle xmlns:a="http://schemas.openxmlformats.org/drawingml/2006/main"/>
           <a:p xmlns:a="http://schemas.openxmlformats.org/drawingml/2006/main">
             <a:pPr algn="l">
+              <a:buNone/>
               <a:defRPr sz="1275" b="0">
                 <a:solidFill>
                   <a:srgbClr val="64748B"/>
@@ -2749,6 +2937,7 @@
           <a:lstStyle xmlns:a="http://schemas.openxmlformats.org/drawingml/2006/main"/>
           <a:p xmlns:a="http://schemas.openxmlformats.org/drawingml/2006/main">
             <a:pPr algn="ctr">
+              <a:buNone/>
               <a:defRPr sz="1500" b="1">
                 <a:solidFill>
                   <a:srgbClr val="059669"/>
@@ -2813,6 +3002,7 @@
           <a:lstStyle xmlns:a="http://schemas.openxmlformats.org/drawingml/2006/main"/>
           <a:p xmlns:a="http://schemas.openxmlformats.org/drawingml/2006/main">
             <a:pPr algn="l">
+              <a:buNone/>
               <a:defRPr sz="1650" b="1">
                 <a:solidFill>
                   <a:srgbClr val="0F172A"/>
@@ -2877,6 +3067,7 @@
           <a:lstStyle xmlns:a="http://schemas.openxmlformats.org/drawingml/2006/main"/>
           <a:p xmlns:a="http://schemas.openxmlformats.org/drawingml/2006/main">
             <a:pPr algn="r">
+              <a:buNone/>
               <a:defRPr sz="1350" b="0">
                 <a:solidFill>
                   <a:srgbClr val="059669"/>
@@ -2973,6 +3164,7 @@
           <a:lstStyle xmlns:a="http://schemas.openxmlformats.org/drawingml/2006/main"/>
           <a:p xmlns:a="http://schemas.openxmlformats.org/drawingml/2006/main">
             <a:pPr algn="ctr">
+              <a:buNone/>
               <a:defRPr sz="1500" b="1">
                 <a:solidFill>
                   <a:srgbClr val="2563EB"/>
@@ -3037,6 +3229,7 @@
           <a:lstStyle xmlns:a="http://schemas.openxmlformats.org/drawingml/2006/main"/>
           <a:p xmlns:a="http://schemas.openxmlformats.org/drawingml/2006/main">
             <a:pPr algn="l">
+              <a:buNone/>
               <a:defRPr sz="1650" b="1">
                 <a:solidFill>
                   <a:srgbClr val="0F172A"/>
@@ -3101,6 +3294,7 @@
           <a:lstStyle xmlns:a="http://schemas.openxmlformats.org/drawingml/2006/main"/>
           <a:p xmlns:a="http://schemas.openxmlformats.org/drawingml/2006/main">
             <a:pPr algn="r">
+              <a:buNone/>
               <a:defRPr sz="1350" b="0">
                 <a:solidFill>
                   <a:srgbClr val="64748B"/>
@@ -3197,6 +3391,7 @@
           <a:lstStyle xmlns:a="http://schemas.openxmlformats.org/drawingml/2006/main"/>
           <a:p xmlns:a="http://schemas.openxmlformats.org/drawingml/2006/main">
             <a:pPr algn="ctr">
+              <a:buNone/>
               <a:defRPr sz="1500" b="1">
                 <a:solidFill>
                   <a:srgbClr val="2563EB"/>
@@ -3261,6 +3456,7 @@
           <a:lstStyle xmlns:a="http://schemas.openxmlformats.org/drawingml/2006/main"/>
           <a:p xmlns:a="http://schemas.openxmlformats.org/drawingml/2006/main">
             <a:pPr algn="l">
+              <a:buNone/>
               <a:defRPr sz="1650" b="1">
                 <a:solidFill>
                   <a:srgbClr val="0F172A"/>
@@ -3325,6 +3521,7 @@
           <a:lstStyle xmlns:a="http://schemas.openxmlformats.org/drawingml/2006/main"/>
           <a:p xmlns:a="http://schemas.openxmlformats.org/drawingml/2006/main">
             <a:pPr algn="r">
+              <a:buNone/>
               <a:defRPr sz="1350" b="0">
                 <a:solidFill>
                   <a:srgbClr val="64748B"/>
@@ -3421,6 +3618,7 @@
           <a:lstStyle xmlns:a="http://schemas.openxmlformats.org/drawingml/2006/main"/>
           <a:p xmlns:a="http://schemas.openxmlformats.org/drawingml/2006/main">
             <a:pPr algn="ctr">
+              <a:buNone/>
               <a:defRPr sz="1500" b="1">
                 <a:solidFill>
                   <a:srgbClr val="2563EB"/>
@@ -3485,6 +3683,7 @@
           <a:lstStyle xmlns:a="http://schemas.openxmlformats.org/drawingml/2006/main"/>
           <a:p xmlns:a="http://schemas.openxmlformats.org/drawingml/2006/main">
             <a:pPr algn="l">
+              <a:buNone/>
               <a:defRPr sz="1650" b="1">
                 <a:solidFill>
                   <a:srgbClr val="0F172A"/>
@@ -3549,6 +3748,7 @@
           <a:lstStyle xmlns:a="http://schemas.openxmlformats.org/drawingml/2006/main"/>
           <a:p xmlns:a="http://schemas.openxmlformats.org/drawingml/2006/main">
             <a:pPr algn="r">
+              <a:buNone/>
               <a:defRPr sz="1350" b="0">
                 <a:solidFill>
                   <a:srgbClr val="64748B"/>
@@ -3645,6 +3845,7 @@
           <a:lstStyle xmlns:a="http://schemas.openxmlformats.org/drawingml/2006/main"/>
           <a:p xmlns:a="http://schemas.openxmlformats.org/drawingml/2006/main">
             <a:pPr algn="ctr">
+              <a:buNone/>
               <a:defRPr sz="1500" b="1">
                 <a:solidFill>
                   <a:srgbClr val="2563EB"/>
@@ -3655,207 +3856,178 @@
               </a:defRPr>
             </a:pPr>
             <a:r>
-              <a:rPr sz="1500" b="1">
-                <a:solidFill>
-                  <a:srgbClr val="2563EB"/>
+              <a:t>5</a:t>
+            </a:r>
+          </a:p>
+        </p:txBody>
+      </p:sp>
+      <p:sp>
+        <p:nvSpPr>
+          <p:cNvPr id="22" name="">
+            <a:extLst xmlns:a="http://schemas.openxmlformats.org/drawingml/2006/main">
+              <a:ext uri="{FF2B5EF4-FFF2-40B4-BE49-F238E27FC236}">
+                <a16:creationId xmlns:a16="http://schemas.microsoft.com/office/drawing/2014/main" id="{19C026DA-187A-4D55-910B-D27D01075767}"/>
+              </a:ext>
+            </a:extLst>
+          </p:cNvPr>
+          <p:cNvSpPr>
+            <a:spLocks xmlns:a="http://schemas.openxmlformats.org/drawingml/2006/main" noGrp="1"/>
+          </p:cNvSpPr>
+          <p:nvPr/>
+        </p:nvSpPr>
+        <p:spPr>
+          <a:xfrm xmlns:a="http://schemas.openxmlformats.org/drawingml/2006/main">
+            <a:off x="1952625" y="4867275"/>
+            <a:ext cx="4953000" cy="247650"/>
+          </a:xfrm>
+          <a:prstGeom xmlns:a="http://schemas.openxmlformats.org/drawingml/2006/main" prst="rect">
+            <a:avLst/>
+          </a:prstGeom>
+          <a:solidFill xmlns:a="http://schemas.openxmlformats.org/drawingml/2006/main">
+            <a:srgbClr val="000000">
+              <a:alpha val="0"/>
+            </a:srgbClr>
+          </a:solidFill>
+          <a:ln xmlns:a="http://schemas.openxmlformats.org/drawingml/2006/main" w="0">
+            <a:solidFill>
+              <a:srgbClr val="000000">
+                <a:alpha val="0"/>
+              </a:srgbClr>
+            </a:solidFill>
+            <a:prstDash val="solid"/>
+          </a:ln>
+        </p:spPr>
+        <p:txBody>
+          <a:bodyPr xmlns:a="http://schemas.openxmlformats.org/drawingml/2006/main" lIns="0" tIns="0" rIns="0" bIns="0" anchor="t"/>
+          <a:lstStyle xmlns:a="http://schemas.openxmlformats.org/drawingml/2006/main"/>
+          <a:p xmlns:a="http://schemas.openxmlformats.org/drawingml/2006/main">
+            <a:pPr algn="l">
+              <a:buNone/>
+              <a:defRPr sz="1650" b="1">
+                <a:solidFill>
+                  <a:srgbClr val="0F172A"/>
+                </a:solidFill>
+                <a:latin typeface="Apple SD Gothic Neo"/>
+                <a:ea typeface="Apple SD Gothic Neo"/>
+                <a:cs typeface="Apple SD Gothic Neo"/>
+              </a:defRPr>
+            </a:pPr>
+            <a:r>
+              <a:t>Parser 품질/section citation 고도화</a:t>
+            </a:r>
+          </a:p>
+        </p:txBody>
+      </p:sp>
+      <p:sp>
+        <p:nvSpPr>
+          <p:cNvPr id="23" name="">
+            <a:extLst xmlns:a="http://schemas.openxmlformats.org/drawingml/2006/main">
+              <a:ext uri="{FF2B5EF4-FFF2-40B4-BE49-F238E27FC236}">
+                <a16:creationId xmlns:a16="http://schemas.microsoft.com/office/drawing/2014/main" id="{539C5BCA-11FD-4006-A406-43AE1E4157D2}"/>
+              </a:ext>
+            </a:extLst>
+          </p:cNvPr>
+          <p:cNvSpPr>
+            <a:spLocks xmlns:a="http://schemas.openxmlformats.org/drawingml/2006/main" noGrp="1"/>
+          </p:cNvSpPr>
+          <p:nvPr/>
+        </p:nvSpPr>
+        <p:spPr>
+          <a:xfrm xmlns:a="http://schemas.openxmlformats.org/drawingml/2006/main">
+            <a:off x="7620000" y="4886325"/>
+            <a:ext cx="2381250" cy="228600"/>
+          </a:xfrm>
+          <a:prstGeom xmlns:a="http://schemas.openxmlformats.org/drawingml/2006/main" prst="rect">
+            <a:avLst/>
+          </a:prstGeom>
+          <a:solidFill xmlns:a="http://schemas.openxmlformats.org/drawingml/2006/main">
+            <a:srgbClr val="000000">
+              <a:alpha val="0"/>
+            </a:srgbClr>
+          </a:solidFill>
+          <a:ln xmlns:a="http://schemas.openxmlformats.org/drawingml/2006/main" w="0">
+            <a:solidFill>
+              <a:srgbClr val="000000">
+                <a:alpha val="0"/>
+              </a:srgbClr>
+            </a:solidFill>
+            <a:prstDash val="solid"/>
+          </a:ln>
+        </p:spPr>
+        <p:txBody>
+          <a:bodyPr xmlns:a="http://schemas.openxmlformats.org/drawingml/2006/main" lIns="0" tIns="0" rIns="0" bIns="0" anchor="t"/>
+          <a:lstStyle xmlns:a="http://schemas.openxmlformats.org/drawingml/2006/main"/>
+          <a:p xmlns:a="http://schemas.openxmlformats.org/drawingml/2006/main">
+            <a:pPr algn="r">
+              <a:buNone/>
+              <a:defRPr sz="1350" b="0">
+                <a:solidFill>
+                  <a:srgbClr val="64748B"/>
+                </a:solidFill>
+                <a:latin typeface="Apple SD Gothic Neo"/>
+                <a:ea typeface="Apple SD Gothic Neo"/>
+                <a:cs typeface="Apple SD Gothic Neo"/>
+              </a:defRPr>
+            </a:pPr>
+            <a:r>
+              <a:t>품질 고도화</a:t>
+            </a:r>
+          </a:p>
+        </p:txBody>
+      </p:sp>
+      <p:sp>
+        <p:nvSpPr>
+          <p:cNvPr id="24" name="">
+            <a:extLst xmlns:a="http://schemas.openxmlformats.org/drawingml/2006/main">
+              <a:ext uri="{FF2B5EF4-FFF2-40B4-BE49-F238E27FC236}">
+                <a16:creationId xmlns:a16="http://schemas.microsoft.com/office/drawing/2014/main" id="{D7B62A20-74B5-4816-9395-56C23B2F8716}"/>
+              </a:ext>
+            </a:extLst>
+          </p:cNvPr>
+          <p:cNvSpPr>
+            <a:spLocks xmlns:a="http://schemas.openxmlformats.org/drawingml/2006/main" noGrp="1"/>
+          </p:cNvSpPr>
+          <p:nvPr/>
+        </p:nvSpPr>
+        <p:spPr>
+          <a:xfrm xmlns:a="http://schemas.openxmlformats.org/drawingml/2006/main">
+            <a:off x="609600" y="6400800"/>
+            <a:ext cx="8572500" cy="228600"/>
+          </a:xfrm>
+          <a:prstGeom xmlns:a="http://schemas.openxmlformats.org/drawingml/2006/main" prst="rect">
+            <a:avLst/>
+          </a:prstGeom>
+          <a:solidFill xmlns:a="http://schemas.openxmlformats.org/drawingml/2006/main">
+            <a:srgbClr val="000000">
+              <a:alpha val="0"/>
+            </a:srgbClr>
+          </a:solidFill>
+          <a:ln xmlns:a="http://schemas.openxmlformats.org/drawingml/2006/main" w="0">
+            <a:solidFill>
+              <a:srgbClr val="000000">
+                <a:alpha val="0"/>
+              </a:srgbClr>
+            </a:solidFill>
+            <a:prstDash val="solid"/>
+          </a:ln>
+        </p:spPr>
+        <p:txBody>
+          <a:bodyPr xmlns:a="http://schemas.openxmlformats.org/drawingml/2006/main" lIns="0" tIns="0" rIns="0" bIns="0" anchor="t"/>
+          <a:lstStyle xmlns:a="http://schemas.openxmlformats.org/drawingml/2006/main"/>
+          <a:p xmlns:a="http://schemas.openxmlformats.org/drawingml/2006/main">
+            <a:pPr algn="l">
+              <a:buNone/>
+              <a:defRPr sz="1050" b="0">
+                <a:solidFill>
+                  <a:srgbClr val="64748B"/>
                 </a:solidFill>
                 <a:latin typeface="Aptos"/>
                 <a:ea typeface="Aptos"/>
                 <a:cs typeface="Aptos"/>
-              </a:rPr>
-              <a:t>5</a:t>
-            </a:r>
-          </a:p>
-        </p:txBody>
-      </p:sp>
-      <p:sp>
-        <p:nvSpPr>
-          <p:cNvPr id="22" name="">
-            <a:extLst xmlns:a="http://schemas.openxmlformats.org/drawingml/2006/main">
-              <a:ext uri="{FF2B5EF4-FFF2-40B4-BE49-F238E27FC236}">
-                <a16:creationId xmlns:a16="http://schemas.microsoft.com/office/drawing/2014/main" id="{19C026DA-187A-4D55-910B-D27D01075767}"/>
-              </a:ext>
-            </a:extLst>
-          </p:cNvPr>
-          <p:cNvSpPr>
-            <a:spLocks xmlns:a="http://schemas.openxmlformats.org/drawingml/2006/main" noGrp="1"/>
-          </p:cNvSpPr>
-          <p:nvPr/>
-        </p:nvSpPr>
-        <p:spPr>
-          <a:xfrm xmlns:a="http://schemas.openxmlformats.org/drawingml/2006/main">
-            <a:off x="1952625" y="4867275"/>
-            <a:ext cx="4953000" cy="247650"/>
-          </a:xfrm>
-          <a:prstGeom xmlns:a="http://schemas.openxmlformats.org/drawingml/2006/main" prst="rect">
-            <a:avLst/>
-          </a:prstGeom>
-          <a:solidFill xmlns:a="http://schemas.openxmlformats.org/drawingml/2006/main">
-            <a:srgbClr val="000000">
-              <a:alpha val="0"/>
-            </a:srgbClr>
-          </a:solidFill>
-          <a:ln xmlns:a="http://schemas.openxmlformats.org/drawingml/2006/main" w="0">
-            <a:solidFill>
-              <a:srgbClr val="000000">
-                <a:alpha val="0"/>
-              </a:srgbClr>
-            </a:solidFill>
-            <a:prstDash val="solid"/>
-          </a:ln>
-        </p:spPr>
-        <p:txBody>
-          <a:bodyPr xmlns:a="http://schemas.openxmlformats.org/drawingml/2006/main" lIns="0" tIns="0" rIns="0" bIns="0" anchor="t"/>
-          <a:lstStyle xmlns:a="http://schemas.openxmlformats.org/drawingml/2006/main"/>
-          <a:p xmlns:a="http://schemas.openxmlformats.org/drawingml/2006/main">
-            <a:pPr algn="l">
-              <a:defRPr sz="1650" b="1">
-                <a:solidFill>
-                  <a:srgbClr val="0F172A"/>
-                </a:solidFill>
-                <a:latin typeface="Apple SD Gothic Neo"/>
-                <a:ea typeface="Apple SD Gothic Neo"/>
-                <a:cs typeface="Apple SD Gothic Neo"/>
-              </a:defRPr>
-            </a:pPr>
-            <a:r>
-              <a:rPr sz="1650" b="1">
-                <a:solidFill>
-                  <a:srgbClr val="0F172A"/>
-                </a:solidFill>
-                <a:latin typeface="Apple SD Gothic Neo"/>
-                <a:ea typeface="Apple SD Gothic Neo"/>
-                <a:cs typeface="Apple SD Gothic Neo"/>
-              </a:rPr>
-              <a:t>HWP/PDF parser 검증</a:t>
-            </a:r>
-          </a:p>
-        </p:txBody>
-      </p:sp>
-      <p:sp>
-        <p:nvSpPr>
-          <p:cNvPr id="23" name="">
-            <a:extLst xmlns:a="http://schemas.openxmlformats.org/drawingml/2006/main">
-              <a:ext uri="{FF2B5EF4-FFF2-40B4-BE49-F238E27FC236}">
-                <a16:creationId xmlns:a16="http://schemas.microsoft.com/office/drawing/2014/main" id="{539C5BCA-11FD-4006-A406-43AE1E4157D2}"/>
-              </a:ext>
-            </a:extLst>
-          </p:cNvPr>
-          <p:cNvSpPr>
-            <a:spLocks xmlns:a="http://schemas.openxmlformats.org/drawingml/2006/main" noGrp="1"/>
-          </p:cNvSpPr>
-          <p:nvPr/>
-        </p:nvSpPr>
-        <p:spPr>
-          <a:xfrm xmlns:a="http://schemas.openxmlformats.org/drawingml/2006/main">
-            <a:off x="7620000" y="4886325"/>
-            <a:ext cx="2381250" cy="228600"/>
-          </a:xfrm>
-          <a:prstGeom xmlns:a="http://schemas.openxmlformats.org/drawingml/2006/main" prst="rect">
-            <a:avLst/>
-          </a:prstGeom>
-          <a:solidFill xmlns:a="http://schemas.openxmlformats.org/drawingml/2006/main">
-            <a:srgbClr val="000000">
-              <a:alpha val="0"/>
-            </a:srgbClr>
-          </a:solidFill>
-          <a:ln xmlns:a="http://schemas.openxmlformats.org/drawingml/2006/main" w="0">
-            <a:solidFill>
-              <a:srgbClr val="000000">
-                <a:alpha val="0"/>
-              </a:srgbClr>
-            </a:solidFill>
-            <a:prstDash val="solid"/>
-          </a:ln>
-        </p:spPr>
-        <p:txBody>
-          <a:bodyPr xmlns:a="http://schemas.openxmlformats.org/drawingml/2006/main" lIns="0" tIns="0" rIns="0" bIns="0" anchor="t"/>
-          <a:lstStyle xmlns:a="http://schemas.openxmlformats.org/drawingml/2006/main"/>
-          <a:p xmlns:a="http://schemas.openxmlformats.org/drawingml/2006/main">
-            <a:pPr algn="r">
-              <a:defRPr sz="1350" b="0">
-                <a:solidFill>
-                  <a:srgbClr val="64748B"/>
-                </a:solidFill>
-                <a:latin typeface="Apple SD Gothic Neo"/>
-                <a:ea typeface="Apple SD Gothic Neo"/>
-                <a:cs typeface="Apple SD Gothic Neo"/>
-              </a:defRPr>
-            </a:pPr>
-            <a:r>
-              <a:rPr sz="1350" b="0">
-                <a:solidFill>
-                  <a:srgbClr val="64748B"/>
-                </a:solidFill>
-                <a:latin typeface="Apple SD Gothic Neo"/>
-                <a:ea typeface="Apple SD Gothic Neo"/>
-                <a:cs typeface="Apple SD Gothic Neo"/>
-              </a:rPr>
-              <a:t>원문 확장</a:t>
-            </a:r>
-          </a:p>
-        </p:txBody>
-      </p:sp>
-      <p:sp>
-        <p:nvSpPr>
-          <p:cNvPr id="24" name="">
-            <a:extLst xmlns:a="http://schemas.openxmlformats.org/drawingml/2006/main">
-              <a:ext uri="{FF2B5EF4-FFF2-40B4-BE49-F238E27FC236}">
-                <a16:creationId xmlns:a16="http://schemas.microsoft.com/office/drawing/2014/main" id="{D7B62A20-74B5-4816-9395-56C23B2F8716}"/>
-              </a:ext>
-            </a:extLst>
-          </p:cNvPr>
-          <p:cNvSpPr>
-            <a:spLocks xmlns:a="http://schemas.openxmlformats.org/drawingml/2006/main" noGrp="1"/>
-          </p:cNvSpPr>
-          <p:nvPr/>
-        </p:nvSpPr>
-        <p:spPr>
-          <a:xfrm xmlns:a="http://schemas.openxmlformats.org/drawingml/2006/main">
-            <a:off x="609600" y="6400800"/>
-            <a:ext cx="8572500" cy="228600"/>
-          </a:xfrm>
-          <a:prstGeom xmlns:a="http://schemas.openxmlformats.org/drawingml/2006/main" prst="rect">
-            <a:avLst/>
-          </a:prstGeom>
-          <a:solidFill xmlns:a="http://schemas.openxmlformats.org/drawingml/2006/main">
-            <a:srgbClr val="000000">
-              <a:alpha val="0"/>
-            </a:srgbClr>
-          </a:solidFill>
-          <a:ln xmlns:a="http://schemas.openxmlformats.org/drawingml/2006/main" w="0">
-            <a:solidFill>
-              <a:srgbClr val="000000">
-                <a:alpha val="0"/>
-              </a:srgbClr>
-            </a:solidFill>
-            <a:prstDash val="solid"/>
-          </a:ln>
-        </p:spPr>
-        <p:txBody>
-          <a:bodyPr xmlns:a="http://schemas.openxmlformats.org/drawingml/2006/main" lIns="0" tIns="0" rIns="0" bIns="0" anchor="t"/>
-          <a:lstStyle xmlns:a="http://schemas.openxmlformats.org/drawingml/2006/main"/>
-          <a:p xmlns:a="http://schemas.openxmlformats.org/drawingml/2006/main">
-            <a:pPr algn="l">
-              <a:defRPr sz="1050" b="0">
-                <a:solidFill>
-                  <a:srgbClr val="64748B"/>
-                </a:solidFill>
-                <a:latin typeface="Aptos"/>
-                <a:ea typeface="Aptos"/>
-                <a:cs typeface="Aptos"/>
-              </a:defRPr>
-            </a:pPr>
-            <a:r>
-              <a:rPr sz="1050" b="0">
-                <a:solidFill>
-                  <a:srgbClr val="64748B"/>
-                </a:solidFill>
-                <a:latin typeface="Aptos"/>
-                <a:ea typeface="Aptos"/>
-                <a:cs typeface="Aptos"/>
-              </a:rPr>
-              <a:t>RFP RAG Baseline · CSV-first offline scaffold</a:t>
+              </a:defRPr>
+            </a:pPr>
+            <a:r>
+              <a:t>RFP RAG Baseline · source-first offline scaffold</a:t>
             </a:r>
           </a:p>
         </p:txBody>
@@ -3901,6 +4073,7 @@
           <a:lstStyle xmlns:a="http://schemas.openxmlformats.org/drawingml/2006/main"/>
           <a:p xmlns:a="http://schemas.openxmlformats.org/drawingml/2006/main">
             <a:pPr algn="r">
+              <a:buNone/>
               <a:defRPr sz="1050" b="0">
                 <a:solidFill>
                   <a:srgbClr val="64748B"/>
@@ -4022,6 +4195,7 @@
           <a:lstStyle xmlns:a="http://schemas.openxmlformats.org/drawingml/2006/main"/>
           <a:p xmlns:a="http://schemas.openxmlformats.org/drawingml/2006/main">
             <a:pPr algn="l">
+              <a:buNone/>
               <a:defRPr sz="2550" b="1">
                 <a:solidFill>
                   <a:srgbClr val="0F172A"/>
@@ -4086,6 +4260,7 @@
           <a:lstStyle xmlns:a="http://schemas.openxmlformats.org/drawingml/2006/main"/>
           <a:p xmlns:a="http://schemas.openxmlformats.org/drawingml/2006/main">
             <a:pPr algn="l">
+              <a:buNone/>
               <a:defRPr sz="1275" b="0">
                 <a:solidFill>
                   <a:srgbClr val="64748B"/>
@@ -4246,6 +4421,7 @@
           <a:lstStyle xmlns:a="http://schemas.openxmlformats.org/drawingml/2006/main"/>
           <a:p xmlns:a="http://schemas.openxmlformats.org/drawingml/2006/main">
             <a:pPr algn="l">
+              <a:buNone/>
               <a:defRPr sz="2700" b="1">
                 <a:solidFill>
                   <a:srgbClr val="2563EB"/>
@@ -4310,6 +4486,7 @@
           <a:lstStyle xmlns:a="http://schemas.openxmlformats.org/drawingml/2006/main"/>
           <a:p xmlns:a="http://schemas.openxmlformats.org/drawingml/2006/main">
             <a:pPr algn="l">
+              <a:buNone/>
               <a:defRPr sz="1125" b="0">
                 <a:solidFill>
                   <a:srgbClr val="64748B"/>
@@ -4374,6 +4551,7 @@
           <a:lstStyle xmlns:a="http://schemas.openxmlformats.org/drawingml/2006/main"/>
           <a:p xmlns:a="http://schemas.openxmlformats.org/drawingml/2006/main">
             <a:pPr algn="l">
+              <a:buNone/>
               <a:defRPr sz="2700" b="1">
                 <a:solidFill>
                   <a:srgbClr val="2563EB"/>
@@ -4438,6 +4616,7 @@
           <a:lstStyle xmlns:a="http://schemas.openxmlformats.org/drawingml/2006/main"/>
           <a:p xmlns:a="http://schemas.openxmlformats.org/drawingml/2006/main">
             <a:pPr algn="l">
+              <a:buNone/>
               <a:defRPr sz="1125" b="0">
                 <a:solidFill>
                   <a:srgbClr val="64748B"/>
@@ -4502,6 +4681,7 @@
           <a:lstStyle xmlns:a="http://schemas.openxmlformats.org/drawingml/2006/main"/>
           <a:p xmlns:a="http://schemas.openxmlformats.org/drawingml/2006/main">
             <a:pPr algn="l">
+              <a:buNone/>
               <a:defRPr sz="2700" b="1">
                 <a:solidFill>
                   <a:srgbClr val="2563EB"/>
@@ -4566,6 +4746,7 @@
           <a:lstStyle xmlns:a="http://schemas.openxmlformats.org/drawingml/2006/main"/>
           <a:p xmlns:a="http://schemas.openxmlformats.org/drawingml/2006/main">
             <a:pPr algn="l">
+              <a:buNone/>
               <a:defRPr sz="1125" b="0">
                 <a:solidFill>
                   <a:srgbClr val="64748B"/>
@@ -4630,6 +4811,7 @@
           <a:lstStyle xmlns:a="http://schemas.openxmlformats.org/drawingml/2006/main"/>
           <a:p xmlns:a="http://schemas.openxmlformats.org/drawingml/2006/main">
             <a:pPr algn="l">
+              <a:buNone/>
               <a:defRPr sz="1500" b="0">
                 <a:solidFill>
                   <a:srgbClr val="0F172A"/>
@@ -4640,15 +4822,7 @@
               </a:defRPr>
             </a:pPr>
             <a:r>
-              <a:rPr sz="1500" b="0">
-                <a:solidFill>
-                  <a:srgbClr val="0F172A"/>
-                </a:solidFill>
-                <a:latin typeface="Apple SD Gothic Neo"/>
-                <a:ea typeface="Apple SD Gothic Neo"/>
-                <a:cs typeface="Apple SD Gothic Neo"/>
-              </a:rPr>
-              <a:t>CSV에 정제된 텍스트가 이미 존재하므로, 원문 파싱보다 재현 가능한 RAG baseline을 먼저 구축.</a:t>
+              <a:t>원본 HWP/PDF를 파싱한 artifacts를 RAG 본문으로 쓰고, CSV는 메타데이터 registry로 제한.</a:t>
             </a:r>
           </a:p>
         </p:txBody>
@@ -4694,6 +4868,7 @@
           <a:lstStyle xmlns:a="http://schemas.openxmlformats.org/drawingml/2006/main"/>
           <a:p xmlns:a="http://schemas.openxmlformats.org/drawingml/2006/main">
             <a:pPr algn="l">
+              <a:buNone/>
               <a:defRPr sz="1500" b="0">
                 <a:solidFill>
                   <a:srgbClr val="0F172A"/>
@@ -4758,6 +4933,7 @@
           <a:lstStyle xmlns:a="http://schemas.openxmlformats.org/drawingml/2006/main"/>
           <a:p xmlns:a="http://schemas.openxmlformats.org/drawingml/2006/main">
             <a:pPr algn="l">
+              <a:buNone/>
               <a:defRPr sz="1500" b="0">
                 <a:solidFill>
                   <a:srgbClr val="0F172A"/>
@@ -4822,6 +4998,7 @@
           <a:lstStyle xmlns:a="http://schemas.openxmlformats.org/drawingml/2006/main"/>
           <a:p xmlns:a="http://schemas.openxmlformats.org/drawingml/2006/main">
             <a:pPr algn="l">
+              <a:buNone/>
               <a:defRPr sz="1050" b="0">
                 <a:solidFill>
                   <a:srgbClr val="64748B"/>
@@ -4832,15 +5009,7 @@
               </a:defRPr>
             </a:pPr>
             <a:r>
-              <a:rPr sz="1050" b="0">
-                <a:solidFill>
-                  <a:srgbClr val="64748B"/>
-                </a:solidFill>
-                <a:latin typeface="Aptos"/>
-                <a:ea typeface="Aptos"/>
-                <a:cs typeface="Aptos"/>
-              </a:rPr>
-              <a:t>RFP RAG Baseline · CSV-first offline scaffold</a:t>
+              <a:t>RFP RAG Baseline · source-first offline scaffold</a:t>
             </a:r>
           </a:p>
         </p:txBody>
@@ -4886,6 +5055,7 @@
           <a:lstStyle xmlns:a="http://schemas.openxmlformats.org/drawingml/2006/main"/>
           <a:p xmlns:a="http://schemas.openxmlformats.org/drawingml/2006/main">
             <a:pPr algn="r">
+              <a:buNone/>
               <a:defRPr sz="1050" b="0">
                 <a:solidFill>
                   <a:srgbClr val="64748B"/>
@@ -5007,6 +5177,7 @@
           <a:lstStyle xmlns:a="http://schemas.openxmlformats.org/drawingml/2006/main"/>
           <a:p xmlns:a="http://schemas.openxmlformats.org/drawingml/2006/main">
             <a:pPr algn="l">
+              <a:buNone/>
               <a:defRPr sz="2550" b="1">
                 <a:solidFill>
                   <a:srgbClr val="0F172A"/>
@@ -5071,6 +5242,7 @@
           <a:lstStyle xmlns:a="http://schemas.openxmlformats.org/drawingml/2006/main"/>
           <a:p xmlns:a="http://schemas.openxmlformats.org/drawingml/2006/main">
             <a:pPr algn="l">
+              <a:buNone/>
               <a:defRPr sz="1275" b="0">
                 <a:solidFill>
                   <a:srgbClr val="64748B"/>
@@ -5081,15 +5253,7 @@
               </a:defRPr>
             </a:pPr>
             <a:r>
-              <a:rPr sz="1275" b="0">
-                <a:solidFill>
-                  <a:srgbClr val="64748B"/>
-                </a:solidFill>
-                <a:latin typeface="Apple SD Gothic Neo"/>
-                <a:ea typeface="Apple SD Gothic Neo"/>
-                <a:cs typeface="Apple SD Gothic Neo"/>
-              </a:rPr>
-              <a:t>Unicode 파일명 이슈는 해결했고, MVP 본문은 CSV `텍스트`를 source of truth로 사용한다.</a:t>
+              <a:t>Unicode 파일명 이슈를 해결하고, RAG 본문은 parsed source artifacts를 source of truth로 사용한다.</a:t>
             </a:r>
           </a:p>
         </p:txBody>
@@ -5167,6 +5331,7 @@
           <a:lstStyle xmlns:a="http://schemas.openxmlformats.org/drawingml/2006/main"/>
           <a:p xmlns:a="http://schemas.openxmlformats.org/drawingml/2006/main">
             <a:pPr algn="l">
+              <a:buNone/>
               <a:defRPr sz="2700" b="1">
                 <a:solidFill>
                   <a:srgbClr val="2563EB"/>
@@ -5231,6 +5396,7 @@
           <a:lstStyle xmlns:a="http://schemas.openxmlformats.org/drawingml/2006/main"/>
           <a:p xmlns:a="http://schemas.openxmlformats.org/drawingml/2006/main">
             <a:pPr algn="l">
+              <a:buNone/>
               <a:defRPr sz="1125" b="0">
                 <a:solidFill>
                   <a:srgbClr val="64748B"/>
@@ -5327,6 +5493,7 @@
           <a:lstStyle xmlns:a="http://schemas.openxmlformats.org/drawingml/2006/main"/>
           <a:p xmlns:a="http://schemas.openxmlformats.org/drawingml/2006/main">
             <a:pPr algn="l">
+              <a:buNone/>
               <a:defRPr sz="2700" b="1">
                 <a:solidFill>
                   <a:srgbClr val="2563EB"/>
@@ -5391,6 +5558,7 @@
           <a:lstStyle xmlns:a="http://schemas.openxmlformats.org/drawingml/2006/main"/>
           <a:p xmlns:a="http://schemas.openxmlformats.org/drawingml/2006/main">
             <a:pPr algn="l">
+              <a:buNone/>
               <a:defRPr sz="1125" b="0">
                 <a:solidFill>
                   <a:srgbClr val="64748B"/>
@@ -5401,15 +5569,7 @@
               </a:defRPr>
             </a:pPr>
             <a:r>
-              <a:rPr sz="1125" b="0">
-                <a:solidFill>
-                  <a:srgbClr val="64748B"/>
-                </a:solidFill>
-                <a:latin typeface="Apple SD Gothic Neo"/>
-                <a:ea typeface="Apple SD Gothic Neo"/>
-                <a:cs typeface="Apple SD Gothic Neo"/>
-              </a:rPr>
-              <a:t>non-empty text</a:t>
+              <a:t>parsed source text</a:t>
             </a:r>
           </a:p>
         </p:txBody>
@@ -5487,6 +5647,7 @@
           <a:lstStyle xmlns:a="http://schemas.openxmlformats.org/drawingml/2006/main"/>
           <a:p xmlns:a="http://schemas.openxmlformats.org/drawingml/2006/main">
             <a:pPr algn="l">
+              <a:buNone/>
               <a:defRPr sz="2700" b="1">
                 <a:solidFill>
                   <a:srgbClr val="2563EB"/>
@@ -5551,6 +5712,7 @@
           <a:lstStyle xmlns:a="http://schemas.openxmlformats.org/drawingml/2006/main"/>
           <a:p xmlns:a="http://schemas.openxmlformats.org/drawingml/2006/main">
             <a:pPr algn="l">
+              <a:buNone/>
               <a:defRPr sz="1125" b="0">
                 <a:solidFill>
                   <a:srgbClr val="64748B"/>
@@ -5647,6 +5809,7 @@
           <a:lstStyle xmlns:a="http://schemas.openxmlformats.org/drawingml/2006/main"/>
           <a:p xmlns:a="http://schemas.openxmlformats.org/drawingml/2006/main">
             <a:pPr algn="l">
+              <a:buNone/>
               <a:defRPr sz="2700" b="1">
                 <a:solidFill>
                   <a:srgbClr val="2563EB"/>
@@ -5711,6 +5874,7 @@
           <a:lstStyle xmlns:a="http://schemas.openxmlformats.org/drawingml/2006/main"/>
           <a:p xmlns:a="http://schemas.openxmlformats.org/drawingml/2006/main">
             <a:pPr algn="l">
+              <a:buNone/>
               <a:defRPr sz="1125" b="0">
                 <a:solidFill>
                   <a:srgbClr val="64748B"/>
@@ -5807,6 +5971,7 @@
           <a:lstStyle xmlns:a="http://schemas.openxmlformats.org/drawingml/2006/main"/>
           <a:p xmlns:a="http://schemas.openxmlformats.org/drawingml/2006/main">
             <a:pPr algn="l">
+              <a:buNone/>
               <a:defRPr sz="975" b="1">
                 <a:solidFill>
                   <a:srgbClr val="D97706"/>
@@ -5871,6 +6036,7 @@
           <a:lstStyle xmlns:a="http://schemas.openxmlformats.org/drawingml/2006/main"/>
           <a:p xmlns:a="http://schemas.openxmlformats.org/drawingml/2006/main">
             <a:pPr algn="l">
+              <a:buNone/>
               <a:defRPr sz="1500" b="0">
                 <a:solidFill>
                   <a:srgbClr val="0F172A"/>
@@ -5967,6 +6133,7 @@
           <a:lstStyle xmlns:a="http://schemas.openxmlformats.org/drawingml/2006/main"/>
           <a:p xmlns:a="http://schemas.openxmlformats.org/drawingml/2006/main">
             <a:pPr algn="l">
+              <a:buNone/>
               <a:defRPr sz="975" b="1">
                 <a:solidFill>
                   <a:srgbClr val="2563EB"/>
@@ -5977,15 +6144,7 @@
               </a:defRPr>
             </a:pPr>
             <a:r>
-              <a:rPr sz="975" b="1">
-                <a:solidFill>
-                  <a:srgbClr val="2563EB"/>
-                </a:solidFill>
-                <a:latin typeface="Apple SD Gothic Neo"/>
-                <a:ea typeface="Apple SD Gothic Neo"/>
-                <a:cs typeface="Apple SD Gothic Neo"/>
-              </a:rPr>
-              <a:t>MVP boundary</a:t>
+              <a:t>Source boundary</a:t>
             </a:r>
           </a:p>
         </p:txBody>
@@ -6031,6 +6190,7 @@
           <a:lstStyle xmlns:a="http://schemas.openxmlformats.org/drawingml/2006/main"/>
           <a:p xmlns:a="http://schemas.openxmlformats.org/drawingml/2006/main">
             <a:pPr algn="l">
+              <a:buNone/>
               <a:defRPr sz="1500" b="0">
                 <a:solidFill>
                   <a:srgbClr val="0F172A"/>
@@ -6041,15 +6201,7 @@
               </a:defRPr>
             </a:pPr>
             <a:r>
-              <a:rPr sz="1500" b="0">
-                <a:solidFill>
-                  <a:srgbClr val="0F172A"/>
-                </a:solidFill>
-                <a:latin typeface="Apple SD Gothic Neo"/>
-                <a:ea typeface="Apple SD Gothic Neo"/>
-                <a:cs typeface="Apple SD Gothic Neo"/>
-              </a:rPr>
-              <a:t>HWP/PDF parser 정확도는 stretch. 현재 평가는 CSV 텍스트 기준.</a:t>
+              <a:t>CSV는 metadata registry. 본문 대체 fallback 없이 parser 품질을 별도 계측.</a:t>
             </a:r>
           </a:p>
         </p:txBody>
@@ -6095,6 +6247,7 @@
           <a:lstStyle xmlns:a="http://schemas.openxmlformats.org/drawingml/2006/main"/>
           <a:p xmlns:a="http://schemas.openxmlformats.org/drawingml/2006/main">
             <a:pPr algn="l">
+              <a:buNone/>
               <a:defRPr sz="1050" b="0">
                 <a:solidFill>
                   <a:srgbClr val="64748B"/>
@@ -6105,15 +6258,7 @@
               </a:defRPr>
             </a:pPr>
             <a:r>
-              <a:rPr sz="1050" b="0">
-                <a:solidFill>
-                  <a:srgbClr val="64748B"/>
-                </a:solidFill>
-                <a:latin typeface="Aptos"/>
-                <a:ea typeface="Aptos"/>
-                <a:cs typeface="Aptos"/>
-              </a:rPr>
-              <a:t>RFP RAG Baseline · CSV-first offline scaffold</a:t>
+              <a:t>RFP RAG Baseline · source-first offline scaffold</a:t>
             </a:r>
           </a:p>
         </p:txBody>
@@ -6159,6 +6304,7 @@
           <a:lstStyle xmlns:a="http://schemas.openxmlformats.org/drawingml/2006/main"/>
           <a:p xmlns:a="http://schemas.openxmlformats.org/drawingml/2006/main">
             <a:pPr algn="r">
+              <a:buNone/>
               <a:defRPr sz="1050" b="0">
                 <a:solidFill>
                   <a:srgbClr val="64748B"/>
@@ -6280,6 +6426,7 @@
           <a:lstStyle xmlns:a="http://schemas.openxmlformats.org/drawingml/2006/main"/>
           <a:p xmlns:a="http://schemas.openxmlformats.org/drawingml/2006/main">
             <a:pPr algn="l">
+              <a:buNone/>
               <a:defRPr sz="2550" b="1">
                 <a:solidFill>
                   <a:srgbClr val="0F172A"/>
@@ -6290,15 +6437,7 @@
               </a:defRPr>
             </a:pPr>
             <a:r>
-              <a:rPr sz="2550" b="1">
-                <a:solidFill>
-                  <a:srgbClr val="0F172A"/>
-                </a:solidFill>
-                <a:latin typeface="Apple SD Gothic Neo"/>
-                <a:ea typeface="Apple SD Gothic Neo"/>
-                <a:cs typeface="Apple SD Gothic Neo"/>
-              </a:rPr>
-              <a:t>Architecture: CSV-first RAG pipeline</a:t>
+              <a:t>Architecture: source-first RAG pipeline</a:t>
             </a:r>
           </a:p>
         </p:txBody>
@@ -6344,6 +6483,7 @@
           <a:lstStyle xmlns:a="http://schemas.openxmlformats.org/drawingml/2006/main"/>
           <a:p xmlns:a="http://schemas.openxmlformats.org/drawingml/2006/main">
             <a:pPr algn="l">
+              <a:buNone/>
               <a:defRPr sz="1275" b="0">
                 <a:solidFill>
                   <a:srgbClr val="64748B"/>
@@ -6354,15 +6494,7 @@
               </a:defRPr>
             </a:pPr>
             <a:r>
-              <a:rPr sz="1275" b="0">
-                <a:solidFill>
-                  <a:srgbClr val="64748B"/>
-                </a:solidFill>
-                <a:latin typeface="Apple SD Gothic Neo"/>
-                <a:ea typeface="Apple SD Gothic Neo"/>
-                <a:cs typeface="Apple SD Gothic Neo"/>
-              </a:rPr>
-              <a:t>검사 → chunking → local index → retrieval → cited QA → evaluation/report gate</a:t>
+              <a:t>metadata 검사 → source parsing → chunking → local index → cited QA → evaluation gate</a:t>
             </a:r>
           </a:p>
         </p:txBody>
@@ -6440,6 +6572,7 @@
           <a:lstStyle xmlns:a="http://schemas.openxmlformats.org/drawingml/2006/main"/>
           <a:p xmlns:a="http://schemas.openxmlformats.org/drawingml/2006/main">
             <a:pPr algn="ctr">
+              <a:buNone/>
               <a:defRPr sz="1500" b="1">
                 <a:solidFill>
                   <a:srgbClr val="0F172A"/>
@@ -6450,38 +6583,23 @@
               </a:defRPr>
             </a:pPr>
             <a:r>
-              <a:rPr sz="1500" b="1">
+              <a:t>CSV metadata</a:t>
+            </a:r>
+          </a:p>
+          <a:p xmlns:a="http://schemas.openxmlformats.org/drawingml/2006/main">
+            <a:pPr algn="ctr">
+              <a:buNone/>
+              <a:defRPr sz="1500" b="1">
                 <a:solidFill>
                   <a:srgbClr val="0F172A"/>
                 </a:solidFill>
                 <a:latin typeface="Apple SD Gothic Neo"/>
                 <a:ea typeface="Apple SD Gothic Neo"/>
                 <a:cs typeface="Apple SD Gothic Neo"/>
-              </a:rPr>
-              <a:t>CSV</a:t>
-            </a:r>
-          </a:p>
-          <a:p xmlns:a="http://schemas.openxmlformats.org/drawingml/2006/main">
-            <a:pPr algn="ctr">
-              <a:defRPr sz="1500" b="1">
-                <a:solidFill>
-                  <a:srgbClr val="0F172A"/>
-                </a:solidFill>
-                <a:latin typeface="Apple SD Gothic Neo"/>
-                <a:ea typeface="Apple SD Gothic Neo"/>
-                <a:cs typeface="Apple SD Gothic Neo"/>
-              </a:defRPr>
-            </a:pPr>
-            <a:r>
-              <a:rPr sz="1500" b="1">
-                <a:solidFill>
-                  <a:srgbClr val="0F172A"/>
-                </a:solidFill>
-                <a:latin typeface="Apple SD Gothic Neo"/>
-                <a:ea typeface="Apple SD Gothic Neo"/>
-                <a:cs typeface="Apple SD Gothic Neo"/>
-              </a:rPr>
-              <a:t>텍스트</a:t>
+              </a:defRPr>
+            </a:pPr>
+            <a:r>
+              <a:t>HWP/PDF source</a:t>
             </a:r>
           </a:p>
         </p:txBody>
@@ -6559,6 +6677,7 @@
           <a:lstStyle xmlns:a="http://schemas.openxmlformats.org/drawingml/2006/main"/>
           <a:p xmlns:a="http://schemas.openxmlformats.org/drawingml/2006/main">
             <a:pPr algn="ctr">
+              <a:buNone/>
               <a:defRPr sz="1500" b="1">
                 <a:solidFill>
                   <a:srgbClr val="0F172A"/>
@@ -6582,6 +6701,7 @@
           </a:p>
           <a:p xmlns:a="http://schemas.openxmlformats.org/drawingml/2006/main">
             <a:pPr algn="ctr">
+              <a:buNone/>
               <a:defRPr sz="1500" b="1">
                 <a:solidFill>
                   <a:srgbClr val="0F172A"/>
@@ -6678,6 +6798,7 @@
           <a:lstStyle xmlns:a="http://schemas.openxmlformats.org/drawingml/2006/main"/>
           <a:p xmlns:a="http://schemas.openxmlformats.org/drawingml/2006/main">
             <a:pPr algn="ctr">
+              <a:buNone/>
               <a:defRPr sz="1500" b="1">
                 <a:solidFill>
                   <a:srgbClr val="0F172A"/>
@@ -6774,6 +6895,7 @@
           <a:lstStyle xmlns:a="http://schemas.openxmlformats.org/drawingml/2006/main"/>
           <a:p xmlns:a="http://schemas.openxmlformats.org/drawingml/2006/main">
             <a:pPr algn="ctr">
+              <a:buNone/>
               <a:defRPr sz="1500" b="1">
                 <a:solidFill>
                   <a:srgbClr val="0F172A"/>
@@ -6784,19 +6906,12 @@
               </a:defRPr>
             </a:pPr>
             <a:r>
-              <a:rPr sz="1500" b="1">
-                <a:solidFill>
-                  <a:srgbClr val="0F172A"/>
-                </a:solidFill>
-                <a:latin typeface="Apple SD Gothic Neo"/>
-                <a:ea typeface="Apple SD Gothic Neo"/>
-                <a:cs typeface="Apple SD Gothic Neo"/>
-              </a:rPr>
-              <a:t>Fake lexical</a:t>
+              <a:t>Offline vector</a:t>
             </a:r>
           </a:p>
           <a:p xmlns:a="http://schemas.openxmlformats.org/drawingml/2006/main">
             <a:pPr algn="ctr">
+              <a:buNone/>
               <a:defRPr sz="1500" b="1">
                 <a:solidFill>
                   <a:srgbClr val="0F172A"/>
@@ -6893,6 +7008,7 @@
           <a:lstStyle xmlns:a="http://schemas.openxmlformats.org/drawingml/2006/main"/>
           <a:p xmlns:a="http://schemas.openxmlformats.org/drawingml/2006/main">
             <a:pPr algn="ctr">
+              <a:buNone/>
               <a:defRPr sz="1500" b="1">
                 <a:solidFill>
                   <a:srgbClr val="0F172A"/>
@@ -6989,6 +7105,7 @@
           <a:lstStyle xmlns:a="http://schemas.openxmlformats.org/drawingml/2006/main"/>
           <a:p xmlns:a="http://schemas.openxmlformats.org/drawingml/2006/main">
             <a:pPr algn="ctr">
+              <a:buNone/>
               <a:defRPr sz="1500" b="1">
                 <a:solidFill>
                   <a:srgbClr val="0F172A"/>
@@ -7012,6 +7129,7 @@
           </a:p>
           <a:p xmlns:a="http://schemas.openxmlformats.org/drawingml/2006/main">
             <a:pPr algn="ctr">
+              <a:buNone/>
               <a:defRPr sz="1500" b="1">
                 <a:solidFill>
                   <a:srgbClr val="0F172A"/>
@@ -7278,6 +7396,7 @@
           <a:lstStyle xmlns:a="http://schemas.openxmlformats.org/drawingml/2006/main"/>
           <a:p xmlns:a="http://schemas.openxmlformats.org/drawingml/2006/main">
             <a:pPr algn="l">
+              <a:buNone/>
               <a:defRPr sz="1350" b="1">
                 <a:solidFill>
                   <a:srgbClr val="059669"/>
@@ -7342,6 +7461,7 @@
           <a:lstStyle xmlns:a="http://schemas.openxmlformats.org/drawingml/2006/main"/>
           <a:p xmlns:a="http://schemas.openxmlformats.org/drawingml/2006/main">
             <a:pPr algn="l">
+              <a:buNone/>
               <a:defRPr sz="1650" b="1">
                 <a:solidFill>
                   <a:srgbClr val="059669"/>
@@ -7352,15 +7472,7 @@
               </a:defRPr>
             </a:pPr>
             <a:r>
-              <a:rPr sz="1650" b="1">
-                <a:solidFill>
-                  <a:srgbClr val="059669"/>
-                </a:solidFill>
-                <a:latin typeface="Apple SD Gothic Neo"/>
-                <a:ea typeface="Apple SD Gothic Neo"/>
-                <a:cs typeface="Apple SD Gothic Neo"/>
-              </a:rPr>
-              <a:t>55개 offline query로 citation · metadata · abstention 계약 검증</a:t>
+              <a:t>60개 offline query로 citation · metadata · abstention 계약 검증</a:t>
             </a:r>
           </a:p>
         </p:txBody>
@@ -7406,6 +7518,7 @@
           <a:lstStyle xmlns:a="http://schemas.openxmlformats.org/drawingml/2006/main"/>
           <a:p xmlns:a="http://schemas.openxmlformats.org/drawingml/2006/main">
             <a:pPr algn="l">
+              <a:buNone/>
               <a:defRPr sz="1275" b="0">
                 <a:solidFill>
                   <a:srgbClr val="1E293B"/>
@@ -7470,6 +7583,7 @@
           <a:lstStyle xmlns:a="http://schemas.openxmlformats.org/drawingml/2006/main"/>
           <a:p xmlns:a="http://schemas.openxmlformats.org/drawingml/2006/main">
             <a:pPr algn="l">
+              <a:buNone/>
               <a:defRPr sz="1050" b="0">
                 <a:solidFill>
                   <a:srgbClr val="64748B"/>
@@ -7480,15 +7594,7 @@
               </a:defRPr>
             </a:pPr>
             <a:r>
-              <a:rPr sz="1050" b="0">
-                <a:solidFill>
-                  <a:srgbClr val="64748B"/>
-                </a:solidFill>
-                <a:latin typeface="Aptos"/>
-                <a:ea typeface="Aptos"/>
-                <a:cs typeface="Aptos"/>
-              </a:rPr>
-              <a:t>RFP RAG Baseline · CSV-first offline scaffold</a:t>
+              <a:t>RFP RAG Baseline · source-first offline scaffold</a:t>
             </a:r>
           </a:p>
         </p:txBody>
@@ -7534,6 +7640,7 @@
           <a:lstStyle xmlns:a="http://schemas.openxmlformats.org/drawingml/2006/main"/>
           <a:p xmlns:a="http://schemas.openxmlformats.org/drawingml/2006/main">
             <a:pPr algn="r">
+              <a:buNone/>
               <a:defRPr sz="1050" b="0">
                 <a:solidFill>
                   <a:srgbClr val="64748B"/>
@@ -7655,6 +7762,7 @@
           <a:lstStyle xmlns:a="http://schemas.openxmlformats.org/drawingml/2006/main"/>
           <a:p xmlns:a="http://schemas.openxmlformats.org/drawingml/2006/main">
             <a:pPr algn="l">
+              <a:buNone/>
               <a:defRPr sz="2550" b="1">
                 <a:solidFill>
                   <a:srgbClr val="0F172A"/>
@@ -7719,6 +7827,7 @@
           <a:lstStyle xmlns:a="http://schemas.openxmlformats.org/drawingml/2006/main"/>
           <a:p xmlns:a="http://schemas.openxmlformats.org/drawingml/2006/main">
             <a:pPr algn="l">
+              <a:buNone/>
               <a:defRPr sz="1275" b="0">
                 <a:solidFill>
                   <a:srgbClr val="64748B"/>
@@ -7815,6 +7924,7 @@
           <a:lstStyle xmlns:a="http://schemas.openxmlformats.org/drawingml/2006/main"/>
           <a:p xmlns:a="http://schemas.openxmlformats.org/drawingml/2006/main">
             <a:pPr algn="l">
+              <a:buNone/>
               <a:defRPr sz="975" b="1">
                 <a:solidFill>
                   <a:srgbClr val="2563EB"/>
@@ -7879,6 +7989,7 @@
           <a:lstStyle xmlns:a="http://schemas.openxmlformats.org/drawingml/2006/main"/>
           <a:p xmlns:a="http://schemas.openxmlformats.org/drawingml/2006/main">
             <a:pPr algn="l">
+              <a:buNone/>
               <a:defRPr sz="1575" b="0">
                 <a:solidFill>
                   <a:srgbClr val="2563EB"/>
@@ -7943,6 +8054,7 @@
           <a:lstStyle xmlns:a="http://schemas.openxmlformats.org/drawingml/2006/main"/>
           <a:p xmlns:a="http://schemas.openxmlformats.org/drawingml/2006/main">
             <a:pPr algn="l">
+              <a:buNone/>
               <a:defRPr sz="1575" b="0">
                 <a:solidFill>
                   <a:srgbClr val="0F172A"/>
@@ -8007,6 +8119,7 @@
           <a:lstStyle xmlns:a="http://schemas.openxmlformats.org/drawingml/2006/main"/>
           <a:p xmlns:a="http://schemas.openxmlformats.org/drawingml/2006/main">
             <a:pPr algn="l">
+              <a:buNone/>
               <a:defRPr sz="1575" b="0">
                 <a:solidFill>
                   <a:srgbClr val="2563EB"/>
@@ -8071,6 +8184,7 @@
           <a:lstStyle xmlns:a="http://schemas.openxmlformats.org/drawingml/2006/main"/>
           <a:p xmlns:a="http://schemas.openxmlformats.org/drawingml/2006/main">
             <a:pPr algn="l">
+              <a:buNone/>
               <a:defRPr sz="1575" b="0">
                 <a:solidFill>
                   <a:srgbClr val="0F172A"/>
@@ -8135,6 +8249,7 @@
           <a:lstStyle xmlns:a="http://schemas.openxmlformats.org/drawingml/2006/main"/>
           <a:p xmlns:a="http://schemas.openxmlformats.org/drawingml/2006/main">
             <a:pPr algn="l">
+              <a:buNone/>
               <a:defRPr sz="1575" b="0">
                 <a:solidFill>
                   <a:srgbClr val="2563EB"/>
@@ -8199,6 +8314,7 @@
           <a:lstStyle xmlns:a="http://schemas.openxmlformats.org/drawingml/2006/main"/>
           <a:p xmlns:a="http://schemas.openxmlformats.org/drawingml/2006/main">
             <a:pPr algn="l">
+              <a:buNone/>
               <a:defRPr sz="1575" b="0">
                 <a:solidFill>
                   <a:srgbClr val="0F172A"/>
@@ -8263,6 +8379,7 @@
           <a:lstStyle xmlns:a="http://schemas.openxmlformats.org/drawingml/2006/main"/>
           <a:p xmlns:a="http://schemas.openxmlformats.org/drawingml/2006/main">
             <a:pPr algn="l">
+              <a:buNone/>
               <a:defRPr sz="1575" b="0">
                 <a:solidFill>
                   <a:srgbClr val="2563EB"/>
@@ -8327,6 +8444,7 @@
           <a:lstStyle xmlns:a="http://schemas.openxmlformats.org/drawingml/2006/main"/>
           <a:p xmlns:a="http://schemas.openxmlformats.org/drawingml/2006/main">
             <a:pPr algn="l">
+              <a:buNone/>
               <a:defRPr sz="1575" b="0">
                 <a:solidFill>
                   <a:srgbClr val="0F172A"/>
@@ -8423,6 +8541,7 @@
           <a:lstStyle xmlns:a="http://schemas.openxmlformats.org/drawingml/2006/main"/>
           <a:p xmlns:a="http://schemas.openxmlformats.org/drawingml/2006/main">
             <a:pPr algn="l">
+              <a:buNone/>
               <a:defRPr sz="975" b="1">
                 <a:solidFill>
                   <a:srgbClr val="2563EB"/>
@@ -8487,6 +8606,7 @@
           <a:lstStyle xmlns:a="http://schemas.openxmlformats.org/drawingml/2006/main"/>
           <a:p xmlns:a="http://schemas.openxmlformats.org/drawingml/2006/main">
             <a:pPr algn="l">
+              <a:buNone/>
               <a:defRPr sz="1575" b="0">
                 <a:solidFill>
                   <a:srgbClr val="2563EB"/>
@@ -8551,6 +8671,7 @@
           <a:lstStyle xmlns:a="http://schemas.openxmlformats.org/drawingml/2006/main"/>
           <a:p xmlns:a="http://schemas.openxmlformats.org/drawingml/2006/main">
             <a:pPr algn="l">
+              <a:buNone/>
               <a:defRPr sz="1575" b="0">
                 <a:solidFill>
                   <a:srgbClr val="0F172A"/>
@@ -8615,6 +8736,7 @@
           <a:lstStyle xmlns:a="http://schemas.openxmlformats.org/drawingml/2006/main"/>
           <a:p xmlns:a="http://schemas.openxmlformats.org/drawingml/2006/main">
             <a:pPr algn="l">
+              <a:buNone/>
               <a:defRPr sz="1575" b="0">
                 <a:solidFill>
                   <a:srgbClr val="2563EB"/>
@@ -8679,6 +8801,7 @@
           <a:lstStyle xmlns:a="http://schemas.openxmlformats.org/drawingml/2006/main"/>
           <a:p xmlns:a="http://schemas.openxmlformats.org/drawingml/2006/main">
             <a:pPr algn="l">
+              <a:buNone/>
               <a:defRPr sz="1575" b="0">
                 <a:solidFill>
                   <a:srgbClr val="0F172A"/>
@@ -8743,6 +8866,7 @@
           <a:lstStyle xmlns:a="http://schemas.openxmlformats.org/drawingml/2006/main"/>
           <a:p xmlns:a="http://schemas.openxmlformats.org/drawingml/2006/main">
             <a:pPr algn="l">
+              <a:buNone/>
               <a:defRPr sz="1575" b="0">
                 <a:solidFill>
                   <a:srgbClr val="2563EB"/>
@@ -8807,6 +8931,7 @@
           <a:lstStyle xmlns:a="http://schemas.openxmlformats.org/drawingml/2006/main"/>
           <a:p xmlns:a="http://schemas.openxmlformats.org/drawingml/2006/main">
             <a:pPr algn="l">
+              <a:buNone/>
               <a:defRPr sz="1575" b="0">
                 <a:solidFill>
                   <a:srgbClr val="0F172A"/>
@@ -8871,6 +8996,7 @@
           <a:lstStyle xmlns:a="http://schemas.openxmlformats.org/drawingml/2006/main"/>
           <a:p xmlns:a="http://schemas.openxmlformats.org/drawingml/2006/main">
             <a:pPr algn="l">
+              <a:buNone/>
               <a:defRPr sz="1575" b="0">
                 <a:solidFill>
                   <a:srgbClr val="2563EB"/>
@@ -8935,6 +9061,7 @@
           <a:lstStyle xmlns:a="http://schemas.openxmlformats.org/drawingml/2006/main"/>
           <a:p xmlns:a="http://schemas.openxmlformats.org/drawingml/2006/main">
             <a:pPr algn="l">
+              <a:buNone/>
               <a:defRPr sz="1575" b="0">
                 <a:solidFill>
                   <a:srgbClr val="0F172A"/>
@@ -8999,6 +9126,7 @@
           <a:lstStyle xmlns:a="http://schemas.openxmlformats.org/drawingml/2006/main"/>
           <a:p xmlns:a="http://schemas.openxmlformats.org/drawingml/2006/main">
             <a:pPr algn="l">
+              <a:buNone/>
               <a:defRPr sz="1050" b="0">
                 <a:solidFill>
                   <a:srgbClr val="64748B"/>
@@ -9009,15 +9137,7 @@
               </a:defRPr>
             </a:pPr>
             <a:r>
-              <a:rPr sz="1050" b="0">
-                <a:solidFill>
-                  <a:srgbClr val="64748B"/>
-                </a:solidFill>
-                <a:latin typeface="Aptos"/>
-                <a:ea typeface="Aptos"/>
-                <a:cs typeface="Aptos"/>
-              </a:rPr>
-              <a:t>RFP RAG Baseline · CSV-first offline scaffold</a:t>
+              <a:t>RFP RAG Baseline · source-first offline scaffold</a:t>
             </a:r>
           </a:p>
         </p:txBody>
@@ -9063,6 +9183,7 @@
           <a:lstStyle xmlns:a="http://schemas.openxmlformats.org/drawingml/2006/main"/>
           <a:p xmlns:a="http://schemas.openxmlformats.org/drawingml/2006/main">
             <a:pPr algn="r">
+              <a:buNone/>
               <a:defRPr sz="1050" b="0">
                 <a:solidFill>
                   <a:srgbClr val="64748B"/>
@@ -9184,6 +9305,7 @@
           <a:lstStyle xmlns:a="http://schemas.openxmlformats.org/drawingml/2006/main"/>
           <a:p xmlns:a="http://schemas.openxmlformats.org/drawingml/2006/main">
             <a:pPr algn="l">
+              <a:buNone/>
               <a:defRPr sz="2550" b="1">
                 <a:solidFill>
                   <a:srgbClr val="0F172A"/>
@@ -9248,6 +9370,7 @@
           <a:lstStyle xmlns:a="http://schemas.openxmlformats.org/drawingml/2006/main"/>
           <a:p xmlns:a="http://schemas.openxmlformats.org/drawingml/2006/main">
             <a:pPr algn="l">
+              <a:buNone/>
               <a:defRPr sz="1275" b="0">
                 <a:solidFill>
                   <a:srgbClr val="64748B"/>
@@ -9258,15 +9381,7 @@
               </a:defRPr>
             </a:pPr>
             <a:r>
-              <a:rPr sz="1275" b="0">
-                <a:solidFill>
-                  <a:srgbClr val="64748B"/>
-                </a:solidFill>
-                <a:latin typeface="Apple SD Gothic Neo"/>
-                <a:ea typeface="Apple SD Gothic Neo"/>
-                <a:cs typeface="Apple SD Gothic Neo"/>
-              </a:rPr>
-              <a:t>55개 deterministic offline query로 구조·인용·abstention 계약을 검증한다.</a:t>
+              <a:t>60개 deterministic offline query로 구조·인용·abstention 계약을 검증한다.</a:t>
             </a:r>
           </a:p>
         </p:txBody>
@@ -9344,6 +9459,7 @@
           <a:lstStyle xmlns:a="http://schemas.openxmlformats.org/drawingml/2006/main"/>
           <a:p xmlns:a="http://schemas.openxmlformats.org/drawingml/2006/main">
             <a:pPr algn="l">
+              <a:buNone/>
               <a:defRPr sz="2700" b="1">
                 <a:solidFill>
                   <a:srgbClr val="2563EB"/>
@@ -9408,6 +9524,7 @@
           <a:lstStyle xmlns:a="http://schemas.openxmlformats.org/drawingml/2006/main"/>
           <a:p xmlns:a="http://schemas.openxmlformats.org/drawingml/2006/main">
             <a:pPr algn="l">
+              <a:buNone/>
               <a:defRPr sz="1125" b="0">
                 <a:solidFill>
                   <a:srgbClr val="64748B"/>
@@ -9472,6 +9589,7 @@
           <a:lstStyle xmlns:a="http://schemas.openxmlformats.org/drawingml/2006/main"/>
           <a:p xmlns:a="http://schemas.openxmlformats.org/drawingml/2006/main">
             <a:pPr algn="l">
+              <a:buNone/>
               <a:defRPr sz="1425" b="0">
                 <a:solidFill>
                   <a:srgbClr val="0F172A"/>
@@ -9568,6 +9686,7 @@
           <a:lstStyle xmlns:a="http://schemas.openxmlformats.org/drawingml/2006/main"/>
           <a:p xmlns:a="http://schemas.openxmlformats.org/drawingml/2006/main">
             <a:pPr algn="l">
+              <a:buNone/>
               <a:defRPr sz="2700" b="1">
                 <a:solidFill>
                   <a:srgbClr val="2563EB"/>
@@ -9632,6 +9751,7 @@
           <a:lstStyle xmlns:a="http://schemas.openxmlformats.org/drawingml/2006/main"/>
           <a:p xmlns:a="http://schemas.openxmlformats.org/drawingml/2006/main">
             <a:pPr algn="l">
+              <a:buNone/>
               <a:defRPr sz="1125" b="0">
                 <a:solidFill>
                   <a:srgbClr val="64748B"/>
@@ -9696,6 +9816,7 @@
           <a:lstStyle xmlns:a="http://schemas.openxmlformats.org/drawingml/2006/main"/>
           <a:p xmlns:a="http://schemas.openxmlformats.org/drawingml/2006/main">
             <a:pPr algn="l">
+              <a:buNone/>
               <a:defRPr sz="1425" b="0">
                 <a:solidFill>
                   <a:srgbClr val="0F172A"/>
@@ -9792,6 +9913,7 @@
           <a:lstStyle xmlns:a="http://schemas.openxmlformats.org/drawingml/2006/main"/>
           <a:p xmlns:a="http://schemas.openxmlformats.org/drawingml/2006/main">
             <a:pPr algn="l">
+              <a:buNone/>
               <a:defRPr sz="2700" b="1">
                 <a:solidFill>
                   <a:srgbClr val="2563EB"/>
@@ -9802,239 +9924,226 @@
               </a:defRPr>
             </a:pPr>
             <a:r>
-              <a:rPr sz="2700" b="1">
+              <a:t>10</a:t>
+            </a:r>
+          </a:p>
+        </p:txBody>
+      </p:sp>
+      <p:sp>
+        <p:nvSpPr>
+          <p:cNvPr id="14" name="">
+            <a:extLst xmlns:a="http://schemas.openxmlformats.org/drawingml/2006/main">
+              <a:ext uri="{FF2B5EF4-FFF2-40B4-BE49-F238E27FC236}">
+                <a16:creationId xmlns:a16="http://schemas.microsoft.com/office/drawing/2014/main" id="{FAF6D78E-AFF5-4AD8-A08E-C26E5400609E}"/>
+              </a:ext>
+            </a:extLst>
+          </p:cNvPr>
+          <p:cNvSpPr>
+            <a:spLocks xmlns:a="http://schemas.openxmlformats.org/drawingml/2006/main" noGrp="1"/>
+          </p:cNvSpPr>
+          <p:nvPr/>
+        </p:nvSpPr>
+        <p:spPr>
+          <a:xfrm xmlns:a="http://schemas.openxmlformats.org/drawingml/2006/main">
+            <a:off x="6781800" y="2571750"/>
+            <a:ext cx="1714500" cy="381000"/>
+          </a:xfrm>
+          <a:prstGeom xmlns:a="http://schemas.openxmlformats.org/drawingml/2006/main" prst="rect">
+            <a:avLst/>
+          </a:prstGeom>
+          <a:solidFill xmlns:a="http://schemas.openxmlformats.org/drawingml/2006/main">
+            <a:srgbClr val="000000">
+              <a:alpha val="0"/>
+            </a:srgbClr>
+          </a:solidFill>
+          <a:ln xmlns:a="http://schemas.openxmlformats.org/drawingml/2006/main" w="0">
+            <a:solidFill>
+              <a:srgbClr val="000000">
+                <a:alpha val="0"/>
+              </a:srgbClr>
+            </a:solidFill>
+            <a:prstDash val="solid"/>
+          </a:ln>
+        </p:spPr>
+        <p:txBody>
+          <a:bodyPr xmlns:a="http://schemas.openxmlformats.org/drawingml/2006/main" lIns="0" tIns="0" rIns="0" bIns="0" anchor="t"/>
+          <a:lstStyle xmlns:a="http://schemas.openxmlformats.org/drawingml/2006/main"/>
+          <a:p xmlns:a="http://schemas.openxmlformats.org/drawingml/2006/main">
+            <a:pPr algn="l">
+              <a:buNone/>
+              <a:defRPr sz="1125" b="0">
+                <a:solidFill>
+                  <a:srgbClr val="64748B"/>
+                </a:solidFill>
+                <a:latin typeface="Apple SD Gothic Neo"/>
+                <a:ea typeface="Apple SD Gothic Neo"/>
+                <a:cs typeface="Apple SD Gothic Neo"/>
+              </a:defRPr>
+            </a:pPr>
+            <a:r>
+              <a:rPr sz="1125" b="0">
+                <a:solidFill>
+                  <a:srgbClr val="64748B"/>
+                </a:solidFill>
+                <a:latin typeface="Apple SD Gothic Neo"/>
+                <a:ea typeface="Apple SD Gothic Neo"/>
+                <a:cs typeface="Apple SD Gothic Neo"/>
+              </a:rPr>
+              <a:t>abstention</a:t>
+            </a:r>
+          </a:p>
+        </p:txBody>
+      </p:sp>
+      <p:sp>
+        <p:nvSpPr>
+          <p:cNvPr id="15" name="">
+            <a:extLst xmlns:a="http://schemas.openxmlformats.org/drawingml/2006/main">
+              <a:ext uri="{FF2B5EF4-FFF2-40B4-BE49-F238E27FC236}">
+                <a16:creationId xmlns:a16="http://schemas.microsoft.com/office/drawing/2014/main" id="{7190F752-719E-45D4-A6EB-1D0C50BE349A}"/>
+              </a:ext>
+            </a:extLst>
+          </p:cNvPr>
+          <p:cNvSpPr>
+            <a:spLocks xmlns:a="http://schemas.openxmlformats.org/drawingml/2006/main" noGrp="1"/>
+          </p:cNvSpPr>
+          <p:nvPr/>
+        </p:nvSpPr>
+        <p:spPr>
+          <a:xfrm xmlns:a="http://schemas.openxmlformats.org/drawingml/2006/main">
+            <a:off x="6781800" y="3143250"/>
+            <a:ext cx="1714500" cy="571500"/>
+          </a:xfrm>
+          <a:prstGeom xmlns:a="http://schemas.openxmlformats.org/drawingml/2006/main" prst="rect">
+            <a:avLst/>
+          </a:prstGeom>
+          <a:solidFill xmlns:a="http://schemas.openxmlformats.org/drawingml/2006/main">
+            <a:srgbClr val="000000">
+              <a:alpha val="0"/>
+            </a:srgbClr>
+          </a:solidFill>
+          <a:ln xmlns:a="http://schemas.openxmlformats.org/drawingml/2006/main" w="0">
+            <a:solidFill>
+              <a:srgbClr val="000000">
+                <a:alpha val="0"/>
+              </a:srgbClr>
+            </a:solidFill>
+            <a:prstDash val="solid"/>
+          </a:ln>
+        </p:spPr>
+        <p:txBody>
+          <a:bodyPr xmlns:a="http://schemas.openxmlformats.org/drawingml/2006/main" lIns="0" tIns="0" rIns="0" bIns="0" anchor="t"/>
+          <a:lstStyle xmlns:a="http://schemas.openxmlformats.org/drawingml/2006/main"/>
+          <a:p xmlns:a="http://schemas.openxmlformats.org/drawingml/2006/main">
+            <a:pPr algn="l">
+              <a:buNone/>
+              <a:defRPr sz="1425" b="0">
+                <a:solidFill>
+                  <a:srgbClr val="0F172A"/>
+                </a:solidFill>
+                <a:latin typeface="Apple SD Gothic Neo"/>
+                <a:ea typeface="Apple SD Gothic Neo"/>
+                <a:cs typeface="Apple SD Gothic Neo"/>
+              </a:defRPr>
+            </a:pPr>
+            <a:r>
+              <a:rPr sz="1425" b="0">
+                <a:solidFill>
+                  <a:srgbClr val="0F172A"/>
+                </a:solidFill>
+                <a:latin typeface="Apple SD Gothic Neo"/>
+                <a:ea typeface="Apple SD Gothic Neo"/>
+                <a:cs typeface="Apple SD Gothic Neo"/>
+              </a:rPr>
+              <a:t>근거 없는 질문 차단</a:t>
+            </a:r>
+          </a:p>
+        </p:txBody>
+      </p:sp>
+      <p:sp>
+        <p:nvSpPr>
+          <p:cNvPr id="16" name="">
+            <a:extLst xmlns:a="http://schemas.openxmlformats.org/drawingml/2006/main">
+              <a:ext uri="{FF2B5EF4-FFF2-40B4-BE49-F238E27FC236}">
+                <a16:creationId xmlns:a16="http://schemas.microsoft.com/office/drawing/2014/main" id="{3147DAAB-DF68-4425-9B8A-9335E9E2C62E}"/>
+              </a:ext>
+            </a:extLst>
+          </p:cNvPr>
+          <p:cNvSpPr>
+            <a:spLocks xmlns:a="http://schemas.openxmlformats.org/drawingml/2006/main" noGrp="1"/>
+          </p:cNvSpPr>
+          <p:nvPr/>
+        </p:nvSpPr>
+        <p:spPr>
+          <a:xfrm xmlns:a="http://schemas.openxmlformats.org/drawingml/2006/main">
+            <a:off x="9334500" y="1714500"/>
+            <a:ext cx="2095500" cy="2476500"/>
+          </a:xfrm>
+          <a:prstGeom xmlns:a="http://schemas.openxmlformats.org/drawingml/2006/main" prst="rect">
+            <a:avLst/>
+          </a:prstGeom>
+          <a:solidFill xmlns:a="http://schemas.openxmlformats.org/drawingml/2006/main">
+            <a:srgbClr val="EFF6FF"/>
+          </a:solidFill>
+          <a:ln xmlns:a="http://schemas.openxmlformats.org/drawingml/2006/main" w="9525">
+            <a:solidFill>
+              <a:srgbClr val="CBD5E1"/>
+            </a:solidFill>
+          </a:ln>
+        </p:spPr>
+      </p:sp>
+      <p:sp>
+        <p:nvSpPr>
+          <p:cNvPr id="17" name="">
+            <a:extLst xmlns:a="http://schemas.openxmlformats.org/drawingml/2006/main">
+              <a:ext uri="{FF2B5EF4-FFF2-40B4-BE49-F238E27FC236}">
+                <a16:creationId xmlns:a16="http://schemas.microsoft.com/office/drawing/2014/main" id="{776CC84E-FD21-42C6-81BB-3FE4DE7AFBF8}"/>
+              </a:ext>
+            </a:extLst>
+          </p:cNvPr>
+          <p:cNvSpPr>
+            <a:spLocks xmlns:a="http://schemas.openxmlformats.org/drawingml/2006/main" noGrp="1"/>
+          </p:cNvSpPr>
+          <p:nvPr/>
+        </p:nvSpPr>
+        <p:spPr>
+          <a:xfrm xmlns:a="http://schemas.openxmlformats.org/drawingml/2006/main">
+            <a:off x="9639300" y="2095500"/>
+            <a:ext cx="1428750" cy="495300"/>
+          </a:xfrm>
+          <a:prstGeom xmlns:a="http://schemas.openxmlformats.org/drawingml/2006/main" prst="rect">
+            <a:avLst/>
+          </a:prstGeom>
+          <a:solidFill xmlns:a="http://schemas.openxmlformats.org/drawingml/2006/main">
+            <a:srgbClr val="000000">
+              <a:alpha val="0"/>
+            </a:srgbClr>
+          </a:solidFill>
+          <a:ln xmlns:a="http://schemas.openxmlformats.org/drawingml/2006/main" w="0">
+            <a:solidFill>
+              <a:srgbClr val="000000">
+                <a:alpha val="0"/>
+              </a:srgbClr>
+            </a:solidFill>
+            <a:prstDash val="solid"/>
+          </a:ln>
+        </p:spPr>
+        <p:txBody>
+          <a:bodyPr xmlns:a="http://schemas.openxmlformats.org/drawingml/2006/main" lIns="0" tIns="0" rIns="0" bIns="0" anchor="t"/>
+          <a:lstStyle xmlns:a="http://schemas.openxmlformats.org/drawingml/2006/main"/>
+          <a:p xmlns:a="http://schemas.openxmlformats.org/drawingml/2006/main">
+            <a:pPr algn="l">
+              <a:buNone/>
+              <a:defRPr sz="2700" b="1">
                 <a:solidFill>
                   <a:srgbClr val="2563EB"/>
                 </a:solidFill>
                 <a:latin typeface="Aptos Display"/>
                 <a:ea typeface="Aptos Display"/>
                 <a:cs typeface="Aptos Display"/>
-              </a:rPr>
-              <a:t>5</a:t>
-            </a:r>
-          </a:p>
-        </p:txBody>
-      </p:sp>
-      <p:sp>
-        <p:nvSpPr>
-          <p:cNvPr id="14" name="">
-            <a:extLst xmlns:a="http://schemas.openxmlformats.org/drawingml/2006/main">
-              <a:ext uri="{FF2B5EF4-FFF2-40B4-BE49-F238E27FC236}">
-                <a16:creationId xmlns:a16="http://schemas.microsoft.com/office/drawing/2014/main" id="{FAF6D78E-AFF5-4AD8-A08E-C26E5400609E}"/>
-              </a:ext>
-            </a:extLst>
-          </p:cNvPr>
-          <p:cNvSpPr>
-            <a:spLocks xmlns:a="http://schemas.openxmlformats.org/drawingml/2006/main" noGrp="1"/>
-          </p:cNvSpPr>
-          <p:nvPr/>
-        </p:nvSpPr>
-        <p:spPr>
-          <a:xfrm xmlns:a="http://schemas.openxmlformats.org/drawingml/2006/main">
-            <a:off x="6781800" y="2571750"/>
-            <a:ext cx="1714500" cy="381000"/>
-          </a:xfrm>
-          <a:prstGeom xmlns:a="http://schemas.openxmlformats.org/drawingml/2006/main" prst="rect">
-            <a:avLst/>
-          </a:prstGeom>
-          <a:solidFill xmlns:a="http://schemas.openxmlformats.org/drawingml/2006/main">
-            <a:srgbClr val="000000">
-              <a:alpha val="0"/>
-            </a:srgbClr>
-          </a:solidFill>
-          <a:ln xmlns:a="http://schemas.openxmlformats.org/drawingml/2006/main" w="0">
-            <a:solidFill>
-              <a:srgbClr val="000000">
-                <a:alpha val="0"/>
-              </a:srgbClr>
-            </a:solidFill>
-            <a:prstDash val="solid"/>
-          </a:ln>
-        </p:spPr>
-        <p:txBody>
-          <a:bodyPr xmlns:a="http://schemas.openxmlformats.org/drawingml/2006/main" lIns="0" tIns="0" rIns="0" bIns="0" anchor="t"/>
-          <a:lstStyle xmlns:a="http://schemas.openxmlformats.org/drawingml/2006/main"/>
-          <a:p xmlns:a="http://schemas.openxmlformats.org/drawingml/2006/main">
-            <a:pPr algn="l">
-              <a:defRPr sz="1125" b="0">
-                <a:solidFill>
-                  <a:srgbClr val="64748B"/>
-                </a:solidFill>
-                <a:latin typeface="Apple SD Gothic Neo"/>
-                <a:ea typeface="Apple SD Gothic Neo"/>
-                <a:cs typeface="Apple SD Gothic Neo"/>
-              </a:defRPr>
-            </a:pPr>
-            <a:r>
-              <a:rPr sz="1125" b="0">
-                <a:solidFill>
-                  <a:srgbClr val="64748B"/>
-                </a:solidFill>
-                <a:latin typeface="Apple SD Gothic Neo"/>
-                <a:ea typeface="Apple SD Gothic Neo"/>
-                <a:cs typeface="Apple SD Gothic Neo"/>
-              </a:rPr>
-              <a:t>abstention</a:t>
-            </a:r>
-          </a:p>
-        </p:txBody>
-      </p:sp>
-      <p:sp>
-        <p:nvSpPr>
-          <p:cNvPr id="15" name="">
-            <a:extLst xmlns:a="http://schemas.openxmlformats.org/drawingml/2006/main">
-              <a:ext uri="{FF2B5EF4-FFF2-40B4-BE49-F238E27FC236}">
-                <a16:creationId xmlns:a16="http://schemas.microsoft.com/office/drawing/2014/main" id="{7190F752-719E-45D4-A6EB-1D0C50BE349A}"/>
-              </a:ext>
-            </a:extLst>
-          </p:cNvPr>
-          <p:cNvSpPr>
-            <a:spLocks xmlns:a="http://schemas.openxmlformats.org/drawingml/2006/main" noGrp="1"/>
-          </p:cNvSpPr>
-          <p:nvPr/>
-        </p:nvSpPr>
-        <p:spPr>
-          <a:xfrm xmlns:a="http://schemas.openxmlformats.org/drawingml/2006/main">
-            <a:off x="6781800" y="3143250"/>
-            <a:ext cx="1714500" cy="571500"/>
-          </a:xfrm>
-          <a:prstGeom xmlns:a="http://schemas.openxmlformats.org/drawingml/2006/main" prst="rect">
-            <a:avLst/>
-          </a:prstGeom>
-          <a:solidFill xmlns:a="http://schemas.openxmlformats.org/drawingml/2006/main">
-            <a:srgbClr val="000000">
-              <a:alpha val="0"/>
-            </a:srgbClr>
-          </a:solidFill>
-          <a:ln xmlns:a="http://schemas.openxmlformats.org/drawingml/2006/main" w="0">
-            <a:solidFill>
-              <a:srgbClr val="000000">
-                <a:alpha val="0"/>
-              </a:srgbClr>
-            </a:solidFill>
-            <a:prstDash val="solid"/>
-          </a:ln>
-        </p:spPr>
-        <p:txBody>
-          <a:bodyPr xmlns:a="http://schemas.openxmlformats.org/drawingml/2006/main" lIns="0" tIns="0" rIns="0" bIns="0" anchor="t"/>
-          <a:lstStyle xmlns:a="http://schemas.openxmlformats.org/drawingml/2006/main"/>
-          <a:p xmlns:a="http://schemas.openxmlformats.org/drawingml/2006/main">
-            <a:pPr algn="l">
-              <a:defRPr sz="1425" b="0">
-                <a:solidFill>
-                  <a:srgbClr val="0F172A"/>
-                </a:solidFill>
-                <a:latin typeface="Apple SD Gothic Neo"/>
-                <a:ea typeface="Apple SD Gothic Neo"/>
-                <a:cs typeface="Apple SD Gothic Neo"/>
-              </a:defRPr>
-            </a:pPr>
-            <a:r>
-              <a:rPr sz="1425" b="0">
-                <a:solidFill>
-                  <a:srgbClr val="0F172A"/>
-                </a:solidFill>
-                <a:latin typeface="Apple SD Gothic Neo"/>
-                <a:ea typeface="Apple SD Gothic Neo"/>
-                <a:cs typeface="Apple SD Gothic Neo"/>
-              </a:rPr>
-              <a:t>근거 없는 질문 차단</a:t>
-            </a:r>
-          </a:p>
-        </p:txBody>
-      </p:sp>
-      <p:sp>
-        <p:nvSpPr>
-          <p:cNvPr id="16" name="">
-            <a:extLst xmlns:a="http://schemas.openxmlformats.org/drawingml/2006/main">
-              <a:ext uri="{FF2B5EF4-FFF2-40B4-BE49-F238E27FC236}">
-                <a16:creationId xmlns:a16="http://schemas.microsoft.com/office/drawing/2014/main" id="{3147DAAB-DF68-4425-9B8A-9335E9E2C62E}"/>
-              </a:ext>
-            </a:extLst>
-          </p:cNvPr>
-          <p:cNvSpPr>
-            <a:spLocks xmlns:a="http://schemas.openxmlformats.org/drawingml/2006/main" noGrp="1"/>
-          </p:cNvSpPr>
-          <p:nvPr/>
-        </p:nvSpPr>
-        <p:spPr>
-          <a:xfrm xmlns:a="http://schemas.openxmlformats.org/drawingml/2006/main">
-            <a:off x="9334500" y="1714500"/>
-            <a:ext cx="2095500" cy="2476500"/>
-          </a:xfrm>
-          <a:prstGeom xmlns:a="http://schemas.openxmlformats.org/drawingml/2006/main" prst="rect">
-            <a:avLst/>
-          </a:prstGeom>
-          <a:solidFill xmlns:a="http://schemas.openxmlformats.org/drawingml/2006/main">
-            <a:srgbClr val="EFF6FF"/>
-          </a:solidFill>
-          <a:ln xmlns:a="http://schemas.openxmlformats.org/drawingml/2006/main" w="9525">
-            <a:solidFill>
-              <a:srgbClr val="CBD5E1"/>
-            </a:solidFill>
-          </a:ln>
-        </p:spPr>
-      </p:sp>
-      <p:sp>
-        <p:nvSpPr>
-          <p:cNvPr id="17" name="">
-            <a:extLst xmlns:a="http://schemas.openxmlformats.org/drawingml/2006/main">
-              <a:ext uri="{FF2B5EF4-FFF2-40B4-BE49-F238E27FC236}">
-                <a16:creationId xmlns:a16="http://schemas.microsoft.com/office/drawing/2014/main" id="{776CC84E-FD21-42C6-81BB-3FE4DE7AFBF8}"/>
-              </a:ext>
-            </a:extLst>
-          </p:cNvPr>
-          <p:cNvSpPr>
-            <a:spLocks xmlns:a="http://schemas.openxmlformats.org/drawingml/2006/main" noGrp="1"/>
-          </p:cNvSpPr>
-          <p:nvPr/>
-        </p:nvSpPr>
-        <p:spPr>
-          <a:xfrm xmlns:a="http://schemas.openxmlformats.org/drawingml/2006/main">
-            <a:off x="9639300" y="2095500"/>
-            <a:ext cx="1428750" cy="495300"/>
-          </a:xfrm>
-          <a:prstGeom xmlns:a="http://schemas.openxmlformats.org/drawingml/2006/main" prst="rect">
-            <a:avLst/>
-          </a:prstGeom>
-          <a:solidFill xmlns:a="http://schemas.openxmlformats.org/drawingml/2006/main">
-            <a:srgbClr val="000000">
-              <a:alpha val="0"/>
-            </a:srgbClr>
-          </a:solidFill>
-          <a:ln xmlns:a="http://schemas.openxmlformats.org/drawingml/2006/main" w="0">
-            <a:solidFill>
-              <a:srgbClr val="000000">
-                <a:alpha val="0"/>
-              </a:srgbClr>
-            </a:solidFill>
-            <a:prstDash val="solid"/>
-          </a:ln>
-        </p:spPr>
-        <p:txBody>
-          <a:bodyPr xmlns:a="http://schemas.openxmlformats.org/drawingml/2006/main" lIns="0" tIns="0" rIns="0" bIns="0" anchor="t"/>
-          <a:lstStyle xmlns:a="http://schemas.openxmlformats.org/drawingml/2006/main"/>
-          <a:p xmlns:a="http://schemas.openxmlformats.org/drawingml/2006/main">
-            <a:pPr algn="l">
-              <a:defRPr sz="2700" b="1">
-                <a:solidFill>
-                  <a:srgbClr val="2563EB"/>
-                </a:solidFill>
-                <a:latin typeface="Aptos Display"/>
-                <a:ea typeface="Aptos Display"/>
-                <a:cs typeface="Aptos Display"/>
-              </a:defRPr>
-            </a:pPr>
-            <a:r>
-              <a:rPr sz="2700" b="1">
-                <a:solidFill>
-                  <a:srgbClr val="2563EB"/>
-                </a:solidFill>
-                <a:latin typeface="Aptos Display"/>
-                <a:ea typeface="Aptos Display"/>
-                <a:cs typeface="Aptos Display"/>
-              </a:rPr>
-              <a:t>55</a:t>
+              </a:defRPr>
+            </a:pPr>
+            <a:r>
+              <a:t>60</a:t>
             </a:r>
           </a:p>
         </p:txBody>
@@ -10080,6 +10189,7 @@
           <a:lstStyle xmlns:a="http://schemas.openxmlformats.org/drawingml/2006/main"/>
           <a:p xmlns:a="http://schemas.openxmlformats.org/drawingml/2006/main">
             <a:pPr algn="l">
+              <a:buNone/>
               <a:defRPr sz="1125" b="0">
                 <a:solidFill>
                   <a:srgbClr val="64748B"/>
@@ -10144,6 +10254,7 @@
           <a:lstStyle xmlns:a="http://schemas.openxmlformats.org/drawingml/2006/main"/>
           <a:p xmlns:a="http://schemas.openxmlformats.org/drawingml/2006/main">
             <a:pPr algn="l">
+              <a:buNone/>
               <a:defRPr sz="975" b="1">
                 <a:solidFill>
                   <a:srgbClr val="2563EB"/>
@@ -10208,6 +10319,7 @@
           <a:lstStyle xmlns:a="http://schemas.openxmlformats.org/drawingml/2006/main"/>
           <a:p xmlns:a="http://schemas.openxmlformats.org/drawingml/2006/main">
             <a:pPr algn="l">
+              <a:buNone/>
               <a:defRPr sz="1650" b="1">
                 <a:solidFill>
                   <a:srgbClr val="0F172A"/>
@@ -10272,6 +10384,7 @@
           <a:lstStyle xmlns:a="http://schemas.openxmlformats.org/drawingml/2006/main"/>
           <a:p xmlns:a="http://schemas.openxmlformats.org/drawingml/2006/main">
             <a:pPr algn="l">
+              <a:buNone/>
               <a:defRPr sz="1050" b="0">
                 <a:solidFill>
                   <a:srgbClr val="64748B"/>
@@ -10282,15 +10395,7 @@
               </a:defRPr>
             </a:pPr>
             <a:r>
-              <a:rPr sz="1050" b="0">
-                <a:solidFill>
-                  <a:srgbClr val="64748B"/>
-                </a:solidFill>
-                <a:latin typeface="Aptos"/>
-                <a:ea typeface="Aptos"/>
-                <a:cs typeface="Aptos"/>
-              </a:rPr>
-              <a:t>RFP RAG Baseline · CSV-first offline scaffold</a:t>
+              <a:t>RFP RAG Baseline · source-first offline scaffold</a:t>
             </a:r>
           </a:p>
         </p:txBody>
@@ -10336,6 +10441,7 @@
           <a:lstStyle xmlns:a="http://schemas.openxmlformats.org/drawingml/2006/main"/>
           <a:p xmlns:a="http://schemas.openxmlformats.org/drawingml/2006/main">
             <a:pPr algn="r">
+              <a:buNone/>
               <a:defRPr sz="1050" b="0">
                 <a:solidFill>
                   <a:srgbClr val="64748B"/>
@@ -10457,6 +10563,7 @@
           <a:lstStyle xmlns:a="http://schemas.openxmlformats.org/drawingml/2006/main"/>
           <a:p xmlns:a="http://schemas.openxmlformats.org/drawingml/2006/main">
             <a:pPr algn="l">
+              <a:buNone/>
               <a:defRPr sz="2550" b="1">
                 <a:solidFill>
                   <a:srgbClr val="0F172A"/>
@@ -10521,6 +10628,7 @@
           <a:lstStyle xmlns:a="http://schemas.openxmlformats.org/drawingml/2006/main"/>
           <a:p xmlns:a="http://schemas.openxmlformats.org/drawingml/2006/main">
             <a:pPr algn="l">
+              <a:buNone/>
               <a:defRPr sz="1275" b="0">
                 <a:solidFill>
                   <a:srgbClr val="64748B"/>
@@ -10617,6 +10725,7 @@
           <a:lstStyle xmlns:a="http://schemas.openxmlformats.org/drawingml/2006/main"/>
           <a:p xmlns:a="http://schemas.openxmlformats.org/drawingml/2006/main">
             <a:pPr algn="l">
+              <a:buNone/>
               <a:defRPr sz="1500" b="0">
                 <a:solidFill>
                   <a:srgbClr val="0F172A"/>
@@ -10681,6 +10790,7 @@
           <a:lstStyle xmlns:a="http://schemas.openxmlformats.org/drawingml/2006/main"/>
           <a:p xmlns:a="http://schemas.openxmlformats.org/drawingml/2006/main">
             <a:pPr algn="r">
+              <a:buNone/>
               <a:defRPr sz="1500" b="1">
                 <a:solidFill>
                   <a:srgbClr val="059669"/>
@@ -10691,15 +10801,7 @@
               </a:defRPr>
             </a:pPr>
             <a:r>
-              <a:rPr sz="1500" b="1">
-                <a:solidFill>
-                  <a:srgbClr val="059669"/>
-                </a:solidFill>
-                <a:latin typeface="Aptos"/>
-                <a:ea typeface="Aptos"/>
-                <a:cs typeface="Aptos"/>
-              </a:rPr>
-              <a:t>1.0</a:t>
+              <a:t>0.96</a:t>
             </a:r>
           </a:p>
         </p:txBody>
@@ -10777,6 +10879,7 @@
           <a:lstStyle xmlns:a="http://schemas.openxmlformats.org/drawingml/2006/main"/>
           <a:p xmlns:a="http://schemas.openxmlformats.org/drawingml/2006/main">
             <a:pPr algn="l">
+              <a:buNone/>
               <a:defRPr sz="1500" b="0">
                 <a:solidFill>
                   <a:srgbClr val="0F172A"/>
@@ -10841,6 +10944,7 @@
           <a:lstStyle xmlns:a="http://schemas.openxmlformats.org/drawingml/2006/main"/>
           <a:p xmlns:a="http://schemas.openxmlformats.org/drawingml/2006/main">
             <a:pPr algn="r">
+              <a:buNone/>
               <a:defRPr sz="1500" b="1">
                 <a:solidFill>
                   <a:srgbClr val="059669"/>
@@ -10851,15 +10955,7 @@
               </a:defRPr>
             </a:pPr>
             <a:r>
-              <a:rPr sz="1500" b="1">
-                <a:solidFill>
-                  <a:srgbClr val="059669"/>
-                </a:solidFill>
-                <a:latin typeface="Aptos"/>
-                <a:ea typeface="Aptos"/>
-                <a:cs typeface="Aptos"/>
-              </a:rPr>
-              <a:t>1.0</a:t>
+              <a:t>0.96</a:t>
             </a:r>
           </a:p>
         </p:txBody>
@@ -10937,6 +11033,7 @@
           <a:lstStyle xmlns:a="http://schemas.openxmlformats.org/drawingml/2006/main"/>
           <a:p xmlns:a="http://schemas.openxmlformats.org/drawingml/2006/main">
             <a:pPr algn="l">
+              <a:buNone/>
               <a:defRPr sz="1500" b="0">
                 <a:solidFill>
                   <a:srgbClr val="0F172A"/>
@@ -11001,6 +11098,7 @@
           <a:lstStyle xmlns:a="http://schemas.openxmlformats.org/drawingml/2006/main"/>
           <a:p xmlns:a="http://schemas.openxmlformats.org/drawingml/2006/main">
             <a:pPr algn="r">
+              <a:buNone/>
               <a:defRPr sz="1500" b="1">
                 <a:solidFill>
                   <a:srgbClr val="059669"/>
@@ -11011,15 +11109,7 @@
               </a:defRPr>
             </a:pPr>
             <a:r>
-              <a:rPr sz="1500" b="1">
-                <a:solidFill>
-                  <a:srgbClr val="059669"/>
-                </a:solidFill>
-                <a:latin typeface="Aptos"/>
-                <a:ea typeface="Aptos"/>
-                <a:cs typeface="Aptos"/>
-              </a:rPr>
-              <a:t>1.0</a:t>
+              <a:t>0.93</a:t>
             </a:r>
           </a:p>
         </p:txBody>
@@ -11097,6 +11187,7 @@
           <a:lstStyle xmlns:a="http://schemas.openxmlformats.org/drawingml/2006/main"/>
           <a:p xmlns:a="http://schemas.openxmlformats.org/drawingml/2006/main">
             <a:pPr algn="l">
+              <a:buNone/>
               <a:defRPr sz="1500" b="0">
                 <a:solidFill>
                   <a:srgbClr val="0F172A"/>
@@ -11161,6 +11252,7 @@
           <a:lstStyle xmlns:a="http://schemas.openxmlformats.org/drawingml/2006/main"/>
           <a:p xmlns:a="http://schemas.openxmlformats.org/drawingml/2006/main">
             <a:pPr algn="r">
+              <a:buNone/>
               <a:defRPr sz="1500" b="1">
                 <a:solidFill>
                   <a:srgbClr val="059669"/>
@@ -11171,14 +11263,6 @@
               </a:defRPr>
             </a:pPr>
             <a:r>
-              <a:rPr sz="1500" b="1">
-                <a:solidFill>
-                  <a:srgbClr val="059669"/>
-                </a:solidFill>
-                <a:latin typeface="Aptos"/>
-                <a:ea typeface="Aptos"/>
-                <a:cs typeface="Aptos"/>
-              </a:rPr>
               <a:t>1.0</a:t>
             </a:r>
           </a:p>
@@ -11257,6 +11341,7 @@
           <a:lstStyle xmlns:a="http://schemas.openxmlformats.org/drawingml/2006/main"/>
           <a:p xmlns:a="http://schemas.openxmlformats.org/drawingml/2006/main">
             <a:pPr algn="l">
+              <a:buNone/>
               <a:defRPr sz="1500" b="0">
                 <a:solidFill>
                   <a:srgbClr val="0F172A"/>
@@ -11321,6 +11406,7 @@
           <a:lstStyle xmlns:a="http://schemas.openxmlformats.org/drawingml/2006/main"/>
           <a:p xmlns:a="http://schemas.openxmlformats.org/drawingml/2006/main">
             <a:pPr algn="r">
+              <a:buNone/>
               <a:defRPr sz="1500" b="1">
                 <a:solidFill>
                   <a:srgbClr val="059669"/>
@@ -11331,15 +11417,7 @@
               </a:defRPr>
             </a:pPr>
             <a:r>
-              <a:rPr sz="1500" b="1">
-                <a:solidFill>
-                  <a:srgbClr val="059669"/>
-                </a:solidFill>
-                <a:latin typeface="Aptos"/>
-                <a:ea typeface="Aptos"/>
-                <a:cs typeface="Aptos"/>
-              </a:rPr>
-              <a:t>1.0</a:t>
+              <a:t>0.96</a:t>
             </a:r>
           </a:p>
         </p:txBody>
@@ -11417,6 +11495,7 @@
           <a:lstStyle xmlns:a="http://schemas.openxmlformats.org/drawingml/2006/main"/>
           <a:p xmlns:a="http://schemas.openxmlformats.org/drawingml/2006/main">
             <a:pPr algn="l">
+              <a:buNone/>
               <a:defRPr sz="1500" b="0">
                 <a:solidFill>
                   <a:srgbClr val="0F172A"/>
@@ -11481,6 +11560,7 @@
           <a:lstStyle xmlns:a="http://schemas.openxmlformats.org/drawingml/2006/main"/>
           <a:p xmlns:a="http://schemas.openxmlformats.org/drawingml/2006/main">
             <a:pPr algn="r">
+              <a:buNone/>
               <a:defRPr sz="1500" b="1">
                 <a:solidFill>
                   <a:srgbClr val="059669"/>
@@ -11491,15 +11571,7 @@
               </a:defRPr>
             </a:pPr>
             <a:r>
-              <a:rPr sz="1500" b="1">
-                <a:solidFill>
-                  <a:srgbClr val="059669"/>
-                </a:solidFill>
-                <a:latin typeface="Aptos"/>
-                <a:ea typeface="Aptos"/>
-                <a:cs typeface="Aptos"/>
-              </a:rPr>
-              <a:t>1.0</a:t>
+              <a:t>0.875</a:t>
             </a:r>
           </a:p>
         </p:txBody>
@@ -11577,6 +11649,7 @@
           <a:lstStyle xmlns:a="http://schemas.openxmlformats.org/drawingml/2006/main"/>
           <a:p xmlns:a="http://schemas.openxmlformats.org/drawingml/2006/main">
             <a:pPr algn="l">
+              <a:buNone/>
               <a:defRPr sz="1500" b="0">
                 <a:solidFill>
                   <a:srgbClr val="0F172A"/>
@@ -11641,6 +11714,7 @@
           <a:lstStyle xmlns:a="http://schemas.openxmlformats.org/drawingml/2006/main"/>
           <a:p xmlns:a="http://schemas.openxmlformats.org/drawingml/2006/main">
             <a:pPr algn="r">
+              <a:buNone/>
               <a:defRPr sz="1500" b="1">
                 <a:solidFill>
                   <a:srgbClr val="059669"/>
@@ -11651,15 +11725,7 @@
               </a:defRPr>
             </a:pPr>
             <a:r>
-              <a:rPr sz="1500" b="1">
-                <a:solidFill>
-                  <a:srgbClr val="059669"/>
-                </a:solidFill>
-                <a:latin typeface="Aptos"/>
-                <a:ea typeface="Aptos"/>
-                <a:cs typeface="Aptos"/>
-              </a:rPr>
-              <a:t>1.0</a:t>
+              <a:t>0.90</a:t>
             </a:r>
           </a:p>
         </p:txBody>
@@ -11769,6 +11835,7 @@
           <a:lstStyle xmlns:a="http://schemas.openxmlformats.org/drawingml/2006/main"/>
           <a:p xmlns:a="http://schemas.openxmlformats.org/drawingml/2006/main">
             <a:pPr algn="l">
+              <a:buNone/>
               <a:defRPr sz="975" b="1">
                 <a:solidFill>
                   <a:srgbClr val="059669"/>
@@ -11833,6 +11900,7 @@
           <a:lstStyle xmlns:a="http://schemas.openxmlformats.org/drawingml/2006/main"/>
           <a:p xmlns:a="http://schemas.openxmlformats.org/drawingml/2006/main">
             <a:pPr algn="l">
+              <a:buNone/>
               <a:defRPr sz="1725" b="1">
                 <a:solidFill>
                   <a:srgbClr val="059669"/>
@@ -11929,6 +11997,7 @@
           <a:lstStyle xmlns:a="http://schemas.openxmlformats.org/drawingml/2006/main"/>
           <a:p xmlns:a="http://schemas.openxmlformats.org/drawingml/2006/main">
             <a:pPr algn="l">
+              <a:buNone/>
               <a:defRPr sz="975" b="1">
                 <a:solidFill>
                   <a:srgbClr val="D97706"/>
@@ -11993,6 +12062,7 @@
           <a:lstStyle xmlns:a="http://schemas.openxmlformats.org/drawingml/2006/main"/>
           <a:p xmlns:a="http://schemas.openxmlformats.org/drawingml/2006/main">
             <a:pPr algn="l">
+              <a:buNone/>
               <a:defRPr sz="1725" b="1">
                 <a:solidFill>
                   <a:srgbClr val="D97706"/>
@@ -12057,6 +12127,7 @@
           <a:lstStyle xmlns:a="http://schemas.openxmlformats.org/drawingml/2006/main"/>
           <a:p xmlns:a="http://schemas.openxmlformats.org/drawingml/2006/main">
             <a:pPr algn="l">
+              <a:buNone/>
               <a:defRPr sz="1050" b="0">
                 <a:solidFill>
                   <a:srgbClr val="64748B"/>
@@ -12067,15 +12138,7 @@
               </a:defRPr>
             </a:pPr>
             <a:r>
-              <a:rPr sz="1050" b="0">
-                <a:solidFill>
-                  <a:srgbClr val="64748B"/>
-                </a:solidFill>
-                <a:latin typeface="Aptos"/>
-                <a:ea typeface="Aptos"/>
-                <a:cs typeface="Aptos"/>
-              </a:rPr>
-              <a:t>RFP RAG Baseline · CSV-first offline scaffold</a:t>
+              <a:t>RFP RAG Baseline · source-first offline scaffold</a:t>
             </a:r>
           </a:p>
         </p:txBody>
@@ -12121,6 +12184,7 @@
           <a:lstStyle xmlns:a="http://schemas.openxmlformats.org/drawingml/2006/main"/>
           <a:p xmlns:a="http://schemas.openxmlformats.org/drawingml/2006/main">
             <a:pPr algn="r">
+              <a:buNone/>
               <a:defRPr sz="1050" b="0">
                 <a:solidFill>
                   <a:srgbClr val="64748B"/>
@@ -12242,6 +12306,7 @@
           <a:lstStyle xmlns:a="http://schemas.openxmlformats.org/drawingml/2006/main"/>
           <a:p xmlns:a="http://schemas.openxmlformats.org/drawingml/2006/main">
             <a:pPr algn="l">
+              <a:buNone/>
               <a:defRPr sz="2550" b="1">
                 <a:solidFill>
                   <a:srgbClr val="0F172A"/>
@@ -12306,6 +12371,7 @@
           <a:lstStyle xmlns:a="http://schemas.openxmlformats.org/drawingml/2006/main"/>
           <a:p xmlns:a="http://schemas.openxmlformats.org/drawingml/2006/main">
             <a:pPr algn="l">
+              <a:buNone/>
               <a:defRPr sz="1275" b="0">
                 <a:solidFill>
                   <a:srgbClr val="64748B"/>
@@ -12402,6 +12468,7 @@
           <a:lstStyle xmlns:a="http://schemas.openxmlformats.org/drawingml/2006/main"/>
           <a:p xmlns:a="http://schemas.openxmlformats.org/drawingml/2006/main">
             <a:pPr algn="l">
+              <a:buNone/>
               <a:defRPr sz="975" b="1">
                 <a:solidFill>
                   <a:srgbClr val="059669"/>
@@ -12466,6 +12533,7 @@
           <a:lstStyle xmlns:a="http://schemas.openxmlformats.org/drawingml/2006/main"/>
           <a:p xmlns:a="http://schemas.openxmlformats.org/drawingml/2006/main">
             <a:pPr algn="l">
+              <a:buNone/>
               <a:defRPr sz="1575" b="1">
                 <a:solidFill>
                   <a:srgbClr val="0F172A"/>
@@ -12530,6 +12598,7 @@
           <a:lstStyle xmlns:a="http://schemas.openxmlformats.org/drawingml/2006/main"/>
           <a:p xmlns:a="http://schemas.openxmlformats.org/drawingml/2006/main">
             <a:pPr algn="l">
+              <a:buNone/>
               <a:defRPr sz="1500" b="0">
                 <a:solidFill>
                   <a:srgbClr val="1E293B"/>
@@ -12594,6 +12663,7 @@
           <a:lstStyle xmlns:a="http://schemas.openxmlformats.org/drawingml/2006/main"/>
           <a:p xmlns:a="http://schemas.openxmlformats.org/drawingml/2006/main">
             <a:pPr algn="l">
+              <a:buNone/>
               <a:defRPr sz="1500" b="1">
                 <a:solidFill>
                   <a:srgbClr val="059669"/>
@@ -12690,6 +12760,7 @@
           <a:lstStyle xmlns:a="http://schemas.openxmlformats.org/drawingml/2006/main"/>
           <a:p xmlns:a="http://schemas.openxmlformats.org/drawingml/2006/main">
             <a:pPr algn="l">
+              <a:buNone/>
               <a:defRPr sz="975" b="1">
                 <a:solidFill>
                   <a:srgbClr val="D97706"/>
@@ -12754,6 +12825,7 @@
           <a:lstStyle xmlns:a="http://schemas.openxmlformats.org/drawingml/2006/main"/>
           <a:p xmlns:a="http://schemas.openxmlformats.org/drawingml/2006/main">
             <a:pPr algn="l">
+              <a:buNone/>
               <a:defRPr sz="1575" b="1">
                 <a:solidFill>
                   <a:srgbClr val="0F172A"/>
@@ -12818,6 +12890,7 @@
           <a:lstStyle xmlns:a="http://schemas.openxmlformats.org/drawingml/2006/main"/>
           <a:p xmlns:a="http://schemas.openxmlformats.org/drawingml/2006/main">
             <a:pPr algn="l">
+              <a:buNone/>
               <a:defRPr sz="1500" b="0">
                 <a:solidFill>
                   <a:srgbClr val="1E293B"/>
@@ -12882,6 +12955,7 @@
           <a:lstStyle xmlns:a="http://schemas.openxmlformats.org/drawingml/2006/main"/>
           <a:p xmlns:a="http://schemas.openxmlformats.org/drawingml/2006/main">
             <a:pPr algn="l">
+              <a:buNone/>
               <a:defRPr sz="1500" b="1">
                 <a:solidFill>
                   <a:srgbClr val="D97706"/>
@@ -12946,6 +13020,7 @@
           <a:lstStyle xmlns:a="http://schemas.openxmlformats.org/drawingml/2006/main"/>
           <a:p xmlns:a="http://schemas.openxmlformats.org/drawingml/2006/main">
             <a:pPr algn="l">
+              <a:buNone/>
               <a:defRPr sz="1050" b="0">
                 <a:solidFill>
                   <a:srgbClr val="64748B"/>
@@ -12956,15 +13031,7 @@
               </a:defRPr>
             </a:pPr>
             <a:r>
-              <a:rPr sz="1050" b="0">
-                <a:solidFill>
-                  <a:srgbClr val="64748B"/>
-                </a:solidFill>
-                <a:latin typeface="Aptos"/>
-                <a:ea typeface="Aptos"/>
-                <a:cs typeface="Aptos"/>
-              </a:rPr>
-              <a:t>RFP RAG Baseline · CSV-first offline scaffold</a:t>
+              <a:t>RFP RAG Baseline · source-first offline scaffold</a:t>
             </a:r>
           </a:p>
         </p:txBody>
@@ -13010,6 +13077,7 @@
           <a:lstStyle xmlns:a="http://schemas.openxmlformats.org/drawingml/2006/main"/>
           <a:p xmlns:a="http://schemas.openxmlformats.org/drawingml/2006/main">
             <a:pPr algn="r">
+              <a:buNone/>
               <a:defRPr sz="1050" b="0">
                 <a:solidFill>
                   <a:srgbClr val="64748B"/>
@@ -13131,6 +13199,7 @@
           <a:lstStyle xmlns:a="http://schemas.openxmlformats.org/drawingml/2006/main"/>
           <a:p xmlns:a="http://schemas.openxmlformats.org/drawingml/2006/main">
             <a:pPr algn="l">
+              <a:buNone/>
               <a:defRPr sz="2550" b="1">
                 <a:solidFill>
                   <a:srgbClr val="0F172A"/>
@@ -13195,6 +13264,7 @@
           <a:lstStyle xmlns:a="http://schemas.openxmlformats.org/drawingml/2006/main"/>
           <a:p xmlns:a="http://schemas.openxmlformats.org/drawingml/2006/main">
             <a:pPr algn="l">
+              <a:buNone/>
               <a:defRPr sz="1275" b="0">
                 <a:solidFill>
                   <a:srgbClr val="64748B"/>
@@ -13291,6 +13361,7 @@
           <a:lstStyle xmlns:a="http://schemas.openxmlformats.org/drawingml/2006/main"/>
           <a:p xmlns:a="http://schemas.openxmlformats.org/drawingml/2006/main">
             <a:pPr algn="l">
+              <a:buNone/>
               <a:defRPr sz="975" b="1">
                 <a:solidFill>
                   <a:srgbClr val="DC2626"/>
@@ -13355,6 +13426,7 @@
           <a:lstStyle xmlns:a="http://schemas.openxmlformats.org/drawingml/2006/main"/>
           <a:p xmlns:a="http://schemas.openxmlformats.org/drawingml/2006/main">
             <a:pPr algn="l">
+              <a:buNone/>
               <a:defRPr sz="1500" b="0">
                 <a:solidFill>
                   <a:srgbClr val="2563EB"/>
@@ -13419,6 +13491,7 @@
           <a:lstStyle xmlns:a="http://schemas.openxmlformats.org/drawingml/2006/main"/>
           <a:p xmlns:a="http://schemas.openxmlformats.org/drawingml/2006/main">
             <a:pPr algn="l">
+              <a:buNone/>
               <a:defRPr sz="1500" b="0">
                 <a:solidFill>
                   <a:srgbClr val="0F172A"/>
@@ -13483,6 +13556,7 @@
           <a:lstStyle xmlns:a="http://schemas.openxmlformats.org/drawingml/2006/main"/>
           <a:p xmlns:a="http://schemas.openxmlformats.org/drawingml/2006/main">
             <a:pPr algn="l">
+              <a:buNone/>
               <a:defRPr sz="1500" b="0">
                 <a:solidFill>
                   <a:srgbClr val="2563EB"/>
@@ -13547,6 +13621,7 @@
           <a:lstStyle xmlns:a="http://schemas.openxmlformats.org/drawingml/2006/main"/>
           <a:p xmlns:a="http://schemas.openxmlformats.org/drawingml/2006/main">
             <a:pPr algn="l">
+              <a:buNone/>
               <a:defRPr sz="1500" b="0">
                 <a:solidFill>
                   <a:srgbClr val="0F172A"/>
@@ -13611,6 +13686,7 @@
           <a:lstStyle xmlns:a="http://schemas.openxmlformats.org/drawingml/2006/main"/>
           <a:p xmlns:a="http://schemas.openxmlformats.org/drawingml/2006/main">
             <a:pPr algn="l">
+              <a:buNone/>
               <a:defRPr sz="1500" b="0">
                 <a:solidFill>
                   <a:srgbClr val="2563EB"/>
@@ -13675,6 +13751,7 @@
           <a:lstStyle xmlns:a="http://schemas.openxmlformats.org/drawingml/2006/main"/>
           <a:p xmlns:a="http://schemas.openxmlformats.org/drawingml/2006/main">
             <a:pPr algn="l">
+              <a:buNone/>
               <a:defRPr sz="1500" b="0">
                 <a:solidFill>
                   <a:srgbClr val="0F172A"/>
@@ -13739,6 +13816,7 @@
           <a:lstStyle xmlns:a="http://schemas.openxmlformats.org/drawingml/2006/main"/>
           <a:p xmlns:a="http://schemas.openxmlformats.org/drawingml/2006/main">
             <a:pPr algn="l">
+              <a:buNone/>
               <a:defRPr sz="1500" b="0">
                 <a:solidFill>
                   <a:srgbClr val="2563EB"/>
@@ -13803,6 +13881,7 @@
           <a:lstStyle xmlns:a="http://schemas.openxmlformats.org/drawingml/2006/main"/>
           <a:p xmlns:a="http://schemas.openxmlformats.org/drawingml/2006/main">
             <a:pPr algn="l">
+              <a:buNone/>
               <a:defRPr sz="1500" b="0">
                 <a:solidFill>
                   <a:srgbClr val="0F172A"/>
@@ -13813,15 +13892,7 @@
               </a:defRPr>
             </a:pPr>
             <a:r>
-              <a:rPr sz="1500" b="0">
-                <a:solidFill>
-                  <a:srgbClr val="0F172A"/>
-                </a:solidFill>
-                <a:latin typeface="Apple SD Gothic Neo"/>
-                <a:ea typeface="Apple SD Gothic Neo"/>
-                <a:cs typeface="Apple SD Gothic Neo"/>
-              </a:rPr>
-              <a:t>원본 HWP/PDF parser는 stretch</a:t>
+              <a:t>표·이미지·차트 이해는 후속 OCR/VLM 평가 필요</a:t>
             </a:r>
           </a:p>
         </p:txBody>
@@ -13899,6 +13970,7 @@
           <a:lstStyle xmlns:a="http://schemas.openxmlformats.org/drawingml/2006/main"/>
           <a:p xmlns:a="http://schemas.openxmlformats.org/drawingml/2006/main">
             <a:pPr algn="l">
+              <a:buNone/>
               <a:defRPr sz="975" b="1">
                 <a:solidFill>
                   <a:srgbClr val="059669"/>
@@ -13963,6 +14035,7 @@
           <a:lstStyle xmlns:a="http://schemas.openxmlformats.org/drawingml/2006/main"/>
           <a:p xmlns:a="http://schemas.openxmlformats.org/drawingml/2006/main">
             <a:pPr algn="l">
+              <a:buNone/>
               <a:defRPr sz="1500" b="0">
                 <a:solidFill>
                   <a:srgbClr val="2563EB"/>
@@ -14027,6 +14100,7 @@
           <a:lstStyle xmlns:a="http://schemas.openxmlformats.org/drawingml/2006/main"/>
           <a:p xmlns:a="http://schemas.openxmlformats.org/drawingml/2006/main">
             <a:pPr algn="l">
+              <a:buNone/>
               <a:defRPr sz="1500" b="0">
                 <a:solidFill>
                   <a:srgbClr val="0F172A"/>
@@ -14091,6 +14165,7 @@
           <a:lstStyle xmlns:a="http://schemas.openxmlformats.org/drawingml/2006/main"/>
           <a:p xmlns:a="http://schemas.openxmlformats.org/drawingml/2006/main">
             <a:pPr algn="l">
+              <a:buNone/>
               <a:defRPr sz="1500" b="0">
                 <a:solidFill>
                   <a:srgbClr val="2563EB"/>
@@ -14155,6 +14230,7 @@
           <a:lstStyle xmlns:a="http://schemas.openxmlformats.org/drawingml/2006/main"/>
           <a:p xmlns:a="http://schemas.openxmlformats.org/drawingml/2006/main">
             <a:pPr algn="l">
+              <a:buNone/>
               <a:defRPr sz="1500" b="0">
                 <a:solidFill>
                   <a:srgbClr val="0F172A"/>
@@ -14219,6 +14295,7 @@
           <a:lstStyle xmlns:a="http://schemas.openxmlformats.org/drawingml/2006/main"/>
           <a:p xmlns:a="http://schemas.openxmlformats.org/drawingml/2006/main">
             <a:pPr algn="l">
+              <a:buNone/>
               <a:defRPr sz="1500" b="0">
                 <a:solidFill>
                   <a:srgbClr val="2563EB"/>
@@ -14283,6 +14360,7 @@
           <a:lstStyle xmlns:a="http://schemas.openxmlformats.org/drawingml/2006/main"/>
           <a:p xmlns:a="http://schemas.openxmlformats.org/drawingml/2006/main">
             <a:pPr algn="l">
+              <a:buNone/>
               <a:defRPr sz="1500" b="0">
                 <a:solidFill>
                   <a:srgbClr val="0F172A"/>
@@ -14347,6 +14425,7 @@
           <a:lstStyle xmlns:a="http://schemas.openxmlformats.org/drawingml/2006/main"/>
           <a:p xmlns:a="http://schemas.openxmlformats.org/drawingml/2006/main">
             <a:pPr algn="l">
+              <a:buNone/>
               <a:defRPr sz="1500" b="0">
                 <a:solidFill>
                   <a:srgbClr val="2563EB"/>
@@ -14411,6 +14490,7 @@
           <a:lstStyle xmlns:a="http://schemas.openxmlformats.org/drawingml/2006/main"/>
           <a:p xmlns:a="http://schemas.openxmlformats.org/drawingml/2006/main">
             <a:pPr algn="l">
+              <a:buNone/>
               <a:defRPr sz="1500" b="0">
                 <a:solidFill>
                   <a:srgbClr val="0F172A"/>
@@ -14475,6 +14555,7 @@
           <a:lstStyle xmlns:a="http://schemas.openxmlformats.org/drawingml/2006/main"/>
           <a:p xmlns:a="http://schemas.openxmlformats.org/drawingml/2006/main">
             <a:pPr algn="l">
+              <a:buNone/>
               <a:defRPr sz="1050" b="0">
                 <a:solidFill>
                   <a:srgbClr val="64748B"/>
@@ -14485,15 +14566,7 @@
               </a:defRPr>
             </a:pPr>
             <a:r>
-              <a:rPr sz="1050" b="0">
-                <a:solidFill>
-                  <a:srgbClr val="64748B"/>
-                </a:solidFill>
-                <a:latin typeface="Aptos"/>
-                <a:ea typeface="Aptos"/>
-                <a:cs typeface="Aptos"/>
-              </a:rPr>
-              <a:t>RFP RAG Baseline · CSV-first offline scaffold</a:t>
+              <a:t>RFP RAG Baseline · source-first offline scaffold</a:t>
             </a:r>
           </a:p>
         </p:txBody>
@@ -14539,6 +14612,7 @@
           <a:lstStyle xmlns:a="http://schemas.openxmlformats.org/drawingml/2006/main"/>
           <a:p xmlns:a="http://schemas.openxmlformats.org/drawingml/2006/main">
             <a:pPr algn="r">
+              <a:buNone/>
               <a:defRPr sz="1050" b="0">
                 <a:solidFill>
                   <a:srgbClr val="64748B"/>

</xml_diff>